<commit_message>
Fix presentation slides for lab defense
</commit_message>
<xml_diff>
--- a/MooseFS.pptx
+++ b/MooseFS.pptx
@@ -10,10 +10,11 @@
     <p:sldId id="263" r:id="rId4"/>
     <p:sldId id="258" r:id="rId5"/>
     <p:sldId id="259" r:id="rId6"/>
-    <p:sldId id="260" r:id="rId7"/>
-    <p:sldId id="261" r:id="rId8"/>
-    <p:sldId id="264" r:id="rId9"/>
-    <p:sldId id="262" r:id="rId10"/>
+    <p:sldId id="265" r:id="rId7"/>
+    <p:sldId id="260" r:id="rId8"/>
+    <p:sldId id="261" r:id="rId9"/>
+    <p:sldId id="264" r:id="rId10"/>
+    <p:sldId id="262" r:id="rId11"/>
   </p:sldIdLst>
   <p:sldSz cx="9144000" cy="6858000" type="screen4x3"/>
   <p:notesSz cx="6858000" cy="9144000"/>
@@ -112,6 +113,22 @@
       </a:defRPr>
     </a:lvl9pPr>
   </p:defaultTextStyle>
+  <p:extLst>
+    <p:ext uri="{EFAFB233-063F-42B5-8137-9DF3F51BA10A}">
+      <p15:sldGuideLst xmlns:p15="http://schemas.microsoft.com/office/powerpoint/2012/main">
+        <p15:guide id="1" orient="horz" pos="2160">
+          <p15:clr>
+            <a:srgbClr val="A4A3A4"/>
+          </p15:clr>
+        </p15:guide>
+        <p15:guide id="2" pos="2880">
+          <p15:clr>
+            <a:srgbClr val="A4A3A4"/>
+          </p15:clr>
+        </p15:guide>
+      </p15:sldGuideLst>
+    </p:ext>
+  </p:extLst>
 </p:presentation>
 </file>
 
@@ -153,10 +170,9 @@
           <a:lstStyle/>
           <a:p>
             <a:r>
-              <a:rPr lang="ru-RU" smtClean="0"/>
+              <a:rPr lang="ru-RU"/>
               <a:t>Образец заголовка</a:t>
             </a:r>
-            <a:endParaRPr lang="ru-RU"/>
           </a:p>
         </p:txBody>
       </p:sp>
@@ -272,10 +288,9 @@
           </a:lstStyle>
           <a:p>
             <a:r>
-              <a:rPr lang="ru-RU" smtClean="0"/>
+              <a:rPr lang="ru-RU"/>
               <a:t>Образец подзаголовка</a:t>
             </a:r>
-            <a:endParaRPr lang="ru-RU"/>
           </a:p>
         </p:txBody>
       </p:sp>
@@ -296,7 +311,7 @@
           <a:p>
             <a:fld id="{B4C71EC6-210F-42DE-9C53-41977AD35B3D}" type="datetimeFigureOut">
               <a:rPr lang="ru-RU" smtClean="0"/>
-              <a:t>17.05.2026</a:t>
+              <a:t>05.09.2026</a:t>
             </a:fld>
             <a:endParaRPr lang="ru-RU"/>
           </a:p>
@@ -385,10 +400,9 @@
           <a:lstStyle/>
           <a:p>
             <a:r>
-              <a:rPr lang="ru-RU" smtClean="0"/>
+              <a:rPr lang="ru-RU"/>
               <a:t>Образец заголовка</a:t>
             </a:r>
-            <a:endParaRPr lang="ru-RU"/>
           </a:p>
         </p:txBody>
       </p:sp>
@@ -409,38 +423,37 @@
           <a:p>
             <a:pPr lvl="0"/>
             <a:r>
-              <a:rPr lang="ru-RU" smtClean="0"/>
+              <a:rPr lang="ru-RU"/>
               <a:t>Образец текста</a:t>
             </a:r>
           </a:p>
           <a:p>
             <a:pPr lvl="1"/>
             <a:r>
-              <a:rPr lang="ru-RU" smtClean="0"/>
+              <a:rPr lang="ru-RU"/>
               <a:t>Второй уровень</a:t>
             </a:r>
           </a:p>
           <a:p>
             <a:pPr lvl="2"/>
             <a:r>
-              <a:rPr lang="ru-RU" smtClean="0"/>
+              <a:rPr lang="ru-RU"/>
               <a:t>Третий уровень</a:t>
             </a:r>
           </a:p>
           <a:p>
             <a:pPr lvl="3"/>
             <a:r>
-              <a:rPr lang="ru-RU" smtClean="0"/>
+              <a:rPr lang="ru-RU"/>
               <a:t>Четвертый уровень</a:t>
             </a:r>
           </a:p>
           <a:p>
             <a:pPr lvl="4"/>
             <a:r>
-              <a:rPr lang="ru-RU" smtClean="0"/>
+              <a:rPr lang="ru-RU"/>
               <a:t>Пятый уровень</a:t>
             </a:r>
-            <a:endParaRPr lang="ru-RU"/>
           </a:p>
         </p:txBody>
       </p:sp>
@@ -461,7 +474,7 @@
           <a:p>
             <a:fld id="{B4C71EC6-210F-42DE-9C53-41977AD35B3D}" type="datetimeFigureOut">
               <a:rPr lang="ru-RU" smtClean="0"/>
-              <a:t>17.05.2026</a:t>
+              <a:t>05.09.2026</a:t>
             </a:fld>
             <a:endParaRPr lang="ru-RU"/>
           </a:p>
@@ -555,10 +568,9 @@
           <a:lstStyle/>
           <a:p>
             <a:r>
-              <a:rPr lang="ru-RU" smtClean="0"/>
+              <a:rPr lang="ru-RU"/>
               <a:t>Образец заголовка</a:t>
             </a:r>
-            <a:endParaRPr lang="ru-RU"/>
           </a:p>
         </p:txBody>
       </p:sp>
@@ -584,38 +596,37 @@
           <a:p>
             <a:pPr lvl="0"/>
             <a:r>
-              <a:rPr lang="ru-RU" smtClean="0"/>
+              <a:rPr lang="ru-RU"/>
               <a:t>Образец текста</a:t>
             </a:r>
           </a:p>
           <a:p>
             <a:pPr lvl="1"/>
             <a:r>
-              <a:rPr lang="ru-RU" smtClean="0"/>
+              <a:rPr lang="ru-RU"/>
               <a:t>Второй уровень</a:t>
             </a:r>
           </a:p>
           <a:p>
             <a:pPr lvl="2"/>
             <a:r>
-              <a:rPr lang="ru-RU" smtClean="0"/>
+              <a:rPr lang="ru-RU"/>
               <a:t>Третий уровень</a:t>
             </a:r>
           </a:p>
           <a:p>
             <a:pPr lvl="3"/>
             <a:r>
-              <a:rPr lang="ru-RU" smtClean="0"/>
+              <a:rPr lang="ru-RU"/>
               <a:t>Четвертый уровень</a:t>
             </a:r>
           </a:p>
           <a:p>
             <a:pPr lvl="4"/>
             <a:r>
-              <a:rPr lang="ru-RU" smtClean="0"/>
+              <a:rPr lang="ru-RU"/>
               <a:t>Пятый уровень</a:t>
             </a:r>
-            <a:endParaRPr lang="ru-RU"/>
           </a:p>
         </p:txBody>
       </p:sp>
@@ -636,7 +647,7 @@
           <a:p>
             <a:fld id="{B4C71EC6-210F-42DE-9C53-41977AD35B3D}" type="datetimeFigureOut">
               <a:rPr lang="ru-RU" smtClean="0"/>
-              <a:t>17.05.2026</a:t>
+              <a:t>05.09.2026</a:t>
             </a:fld>
             <a:endParaRPr lang="ru-RU"/>
           </a:p>
@@ -725,10 +736,9 @@
           <a:lstStyle/>
           <a:p>
             <a:r>
-              <a:rPr lang="ru-RU" smtClean="0"/>
+              <a:rPr lang="ru-RU"/>
               <a:t>Образец заголовка</a:t>
             </a:r>
-            <a:endParaRPr lang="ru-RU"/>
           </a:p>
         </p:txBody>
       </p:sp>
@@ -749,38 +759,37 @@
           <a:p>
             <a:pPr lvl="0"/>
             <a:r>
-              <a:rPr lang="ru-RU" smtClean="0"/>
+              <a:rPr lang="ru-RU"/>
               <a:t>Образец текста</a:t>
             </a:r>
           </a:p>
           <a:p>
             <a:pPr lvl="1"/>
             <a:r>
-              <a:rPr lang="ru-RU" smtClean="0"/>
+              <a:rPr lang="ru-RU"/>
               <a:t>Второй уровень</a:t>
             </a:r>
           </a:p>
           <a:p>
             <a:pPr lvl="2"/>
             <a:r>
-              <a:rPr lang="ru-RU" smtClean="0"/>
+              <a:rPr lang="ru-RU"/>
               <a:t>Третий уровень</a:t>
             </a:r>
           </a:p>
           <a:p>
             <a:pPr lvl="3"/>
             <a:r>
-              <a:rPr lang="ru-RU" smtClean="0"/>
+              <a:rPr lang="ru-RU"/>
               <a:t>Четвертый уровень</a:t>
             </a:r>
           </a:p>
           <a:p>
             <a:pPr lvl="4"/>
             <a:r>
-              <a:rPr lang="ru-RU" smtClean="0"/>
+              <a:rPr lang="ru-RU"/>
               <a:t>Пятый уровень</a:t>
             </a:r>
-            <a:endParaRPr lang="ru-RU"/>
           </a:p>
         </p:txBody>
       </p:sp>
@@ -801,7 +810,7 @@
           <a:p>
             <a:fld id="{B4C71EC6-210F-42DE-9C53-41977AD35B3D}" type="datetimeFigureOut">
               <a:rPr lang="ru-RU" smtClean="0"/>
-              <a:t>17.05.2026</a:t>
+              <a:t>05.09.2026</a:t>
             </a:fld>
             <a:endParaRPr lang="ru-RU"/>
           </a:p>
@@ -899,10 +908,9 @@
           </a:lstStyle>
           <a:p>
             <a:r>
-              <a:rPr lang="ru-RU" smtClean="0"/>
+              <a:rPr lang="ru-RU"/>
               <a:t>Образец заголовка</a:t>
             </a:r>
-            <a:endParaRPr lang="ru-RU"/>
           </a:p>
         </p:txBody>
       </p:sp>
@@ -1019,7 +1027,7 @@
           <a:p>
             <a:pPr lvl="0"/>
             <a:r>
-              <a:rPr lang="ru-RU" smtClean="0"/>
+              <a:rPr lang="ru-RU"/>
               <a:t>Образец текста</a:t>
             </a:r>
           </a:p>
@@ -1042,7 +1050,7 @@
           <a:p>
             <a:fld id="{B4C71EC6-210F-42DE-9C53-41977AD35B3D}" type="datetimeFigureOut">
               <a:rPr lang="ru-RU" smtClean="0"/>
-              <a:t>17.05.2026</a:t>
+              <a:t>05.09.2026</a:t>
             </a:fld>
             <a:endParaRPr lang="ru-RU"/>
           </a:p>
@@ -1131,10 +1139,9 @@
           <a:lstStyle/>
           <a:p>
             <a:r>
-              <a:rPr lang="ru-RU" smtClean="0"/>
+              <a:rPr lang="ru-RU"/>
               <a:t>Образец заголовка</a:t>
             </a:r>
-            <a:endParaRPr lang="ru-RU"/>
           </a:p>
         </p:txBody>
       </p:sp>
@@ -1188,38 +1195,37 @@
           <a:p>
             <a:pPr lvl="0"/>
             <a:r>
-              <a:rPr lang="ru-RU" smtClean="0"/>
+              <a:rPr lang="ru-RU"/>
               <a:t>Образец текста</a:t>
             </a:r>
           </a:p>
           <a:p>
             <a:pPr lvl="1"/>
             <a:r>
-              <a:rPr lang="ru-RU" smtClean="0"/>
+              <a:rPr lang="ru-RU"/>
               <a:t>Второй уровень</a:t>
             </a:r>
           </a:p>
           <a:p>
             <a:pPr lvl="2"/>
             <a:r>
-              <a:rPr lang="ru-RU" smtClean="0"/>
+              <a:rPr lang="ru-RU"/>
               <a:t>Третий уровень</a:t>
             </a:r>
           </a:p>
           <a:p>
             <a:pPr lvl="3"/>
             <a:r>
-              <a:rPr lang="ru-RU" smtClean="0"/>
+              <a:rPr lang="ru-RU"/>
               <a:t>Четвертый уровень</a:t>
             </a:r>
           </a:p>
           <a:p>
             <a:pPr lvl="4"/>
             <a:r>
-              <a:rPr lang="ru-RU" smtClean="0"/>
+              <a:rPr lang="ru-RU"/>
               <a:t>Пятый уровень</a:t>
             </a:r>
-            <a:endParaRPr lang="ru-RU"/>
           </a:p>
         </p:txBody>
       </p:sp>
@@ -1273,38 +1279,37 @@
           <a:p>
             <a:pPr lvl="0"/>
             <a:r>
-              <a:rPr lang="ru-RU" smtClean="0"/>
+              <a:rPr lang="ru-RU"/>
               <a:t>Образец текста</a:t>
             </a:r>
           </a:p>
           <a:p>
             <a:pPr lvl="1"/>
             <a:r>
-              <a:rPr lang="ru-RU" smtClean="0"/>
+              <a:rPr lang="ru-RU"/>
               <a:t>Второй уровень</a:t>
             </a:r>
           </a:p>
           <a:p>
             <a:pPr lvl="2"/>
             <a:r>
-              <a:rPr lang="ru-RU" smtClean="0"/>
+              <a:rPr lang="ru-RU"/>
               <a:t>Третий уровень</a:t>
             </a:r>
           </a:p>
           <a:p>
             <a:pPr lvl="3"/>
             <a:r>
-              <a:rPr lang="ru-RU" smtClean="0"/>
+              <a:rPr lang="ru-RU"/>
               <a:t>Четвертый уровень</a:t>
             </a:r>
           </a:p>
           <a:p>
             <a:pPr lvl="4"/>
             <a:r>
-              <a:rPr lang="ru-RU" smtClean="0"/>
+              <a:rPr lang="ru-RU"/>
               <a:t>Пятый уровень</a:t>
             </a:r>
-            <a:endParaRPr lang="ru-RU"/>
           </a:p>
         </p:txBody>
       </p:sp>
@@ -1325,7 +1330,7 @@
           <a:p>
             <a:fld id="{B4C71EC6-210F-42DE-9C53-41977AD35B3D}" type="datetimeFigureOut">
               <a:rPr lang="ru-RU" smtClean="0"/>
-              <a:t>17.05.2026</a:t>
+              <a:t>05.09.2026</a:t>
             </a:fld>
             <a:endParaRPr lang="ru-RU"/>
           </a:p>
@@ -1418,10 +1423,9 @@
           </a:lstStyle>
           <a:p>
             <a:r>
-              <a:rPr lang="ru-RU" smtClean="0"/>
+              <a:rPr lang="ru-RU"/>
               <a:t>Образец заголовка</a:t>
             </a:r>
-            <a:endParaRPr lang="ru-RU"/>
           </a:p>
         </p:txBody>
       </p:sp>
@@ -1484,7 +1488,7 @@
           <a:p>
             <a:pPr lvl="0"/>
             <a:r>
-              <a:rPr lang="ru-RU" smtClean="0"/>
+              <a:rPr lang="ru-RU"/>
               <a:t>Образец текста</a:t>
             </a:r>
           </a:p>
@@ -1540,38 +1544,37 @@
           <a:p>
             <a:pPr lvl="0"/>
             <a:r>
-              <a:rPr lang="ru-RU" smtClean="0"/>
+              <a:rPr lang="ru-RU"/>
               <a:t>Образец текста</a:t>
             </a:r>
           </a:p>
           <a:p>
             <a:pPr lvl="1"/>
             <a:r>
-              <a:rPr lang="ru-RU" smtClean="0"/>
+              <a:rPr lang="ru-RU"/>
               <a:t>Второй уровень</a:t>
             </a:r>
           </a:p>
           <a:p>
             <a:pPr lvl="2"/>
             <a:r>
-              <a:rPr lang="ru-RU" smtClean="0"/>
+              <a:rPr lang="ru-RU"/>
               <a:t>Третий уровень</a:t>
             </a:r>
           </a:p>
           <a:p>
             <a:pPr lvl="3"/>
             <a:r>
-              <a:rPr lang="ru-RU" smtClean="0"/>
+              <a:rPr lang="ru-RU"/>
               <a:t>Четвертый уровень</a:t>
             </a:r>
           </a:p>
           <a:p>
             <a:pPr lvl="4"/>
             <a:r>
-              <a:rPr lang="ru-RU" smtClean="0"/>
+              <a:rPr lang="ru-RU"/>
               <a:t>Пятый уровень</a:t>
             </a:r>
-            <a:endParaRPr lang="ru-RU"/>
           </a:p>
         </p:txBody>
       </p:sp>
@@ -1634,7 +1637,7 @@
           <a:p>
             <a:pPr lvl="0"/>
             <a:r>
-              <a:rPr lang="ru-RU" smtClean="0"/>
+              <a:rPr lang="ru-RU"/>
               <a:t>Образец текста</a:t>
             </a:r>
           </a:p>
@@ -1690,38 +1693,37 @@
           <a:p>
             <a:pPr lvl="0"/>
             <a:r>
-              <a:rPr lang="ru-RU" smtClean="0"/>
+              <a:rPr lang="ru-RU"/>
               <a:t>Образец текста</a:t>
             </a:r>
           </a:p>
           <a:p>
             <a:pPr lvl="1"/>
             <a:r>
-              <a:rPr lang="ru-RU" smtClean="0"/>
+              <a:rPr lang="ru-RU"/>
               <a:t>Второй уровень</a:t>
             </a:r>
           </a:p>
           <a:p>
             <a:pPr lvl="2"/>
             <a:r>
-              <a:rPr lang="ru-RU" smtClean="0"/>
+              <a:rPr lang="ru-RU"/>
               <a:t>Третий уровень</a:t>
             </a:r>
           </a:p>
           <a:p>
             <a:pPr lvl="3"/>
             <a:r>
-              <a:rPr lang="ru-RU" smtClean="0"/>
+              <a:rPr lang="ru-RU"/>
               <a:t>Четвертый уровень</a:t>
             </a:r>
           </a:p>
           <a:p>
             <a:pPr lvl="4"/>
             <a:r>
-              <a:rPr lang="ru-RU" smtClean="0"/>
+              <a:rPr lang="ru-RU"/>
               <a:t>Пятый уровень</a:t>
             </a:r>
-            <a:endParaRPr lang="ru-RU"/>
           </a:p>
         </p:txBody>
       </p:sp>
@@ -1742,7 +1744,7 @@
           <a:p>
             <a:fld id="{B4C71EC6-210F-42DE-9C53-41977AD35B3D}" type="datetimeFigureOut">
               <a:rPr lang="ru-RU" smtClean="0"/>
-              <a:t>17.05.2026</a:t>
+              <a:t>05.09.2026</a:t>
             </a:fld>
             <a:endParaRPr lang="ru-RU"/>
           </a:p>
@@ -1831,10 +1833,9 @@
           <a:lstStyle/>
           <a:p>
             <a:r>
-              <a:rPr lang="ru-RU" smtClean="0"/>
+              <a:rPr lang="ru-RU"/>
               <a:t>Образец заголовка</a:t>
             </a:r>
-            <a:endParaRPr lang="ru-RU"/>
           </a:p>
         </p:txBody>
       </p:sp>
@@ -1855,7 +1856,7 @@
           <a:p>
             <a:fld id="{B4C71EC6-210F-42DE-9C53-41977AD35B3D}" type="datetimeFigureOut">
               <a:rPr lang="ru-RU" smtClean="0"/>
-              <a:t>17.05.2026</a:t>
+              <a:t>05.09.2026</a:t>
             </a:fld>
             <a:endParaRPr lang="ru-RU"/>
           </a:p>
@@ -1945,7 +1946,7 @@
           <a:p>
             <a:fld id="{B4C71EC6-210F-42DE-9C53-41977AD35B3D}" type="datetimeFigureOut">
               <a:rPr lang="ru-RU" smtClean="0"/>
-              <a:t>17.05.2026</a:t>
+              <a:t>05.09.2026</a:t>
             </a:fld>
             <a:endParaRPr lang="ru-RU"/>
           </a:p>
@@ -2043,10 +2044,9 @@
           </a:lstStyle>
           <a:p>
             <a:r>
-              <a:rPr lang="ru-RU" smtClean="0"/>
+              <a:rPr lang="ru-RU"/>
               <a:t>Образец заголовка</a:t>
             </a:r>
-            <a:endParaRPr lang="ru-RU"/>
           </a:p>
         </p:txBody>
       </p:sp>
@@ -2100,38 +2100,37 @@
           <a:p>
             <a:pPr lvl="0"/>
             <a:r>
-              <a:rPr lang="ru-RU" smtClean="0"/>
+              <a:rPr lang="ru-RU"/>
               <a:t>Образец текста</a:t>
             </a:r>
           </a:p>
           <a:p>
             <a:pPr lvl="1"/>
             <a:r>
-              <a:rPr lang="ru-RU" smtClean="0"/>
+              <a:rPr lang="ru-RU"/>
               <a:t>Второй уровень</a:t>
             </a:r>
           </a:p>
           <a:p>
             <a:pPr lvl="2"/>
             <a:r>
-              <a:rPr lang="ru-RU" smtClean="0"/>
+              <a:rPr lang="ru-RU"/>
               <a:t>Третий уровень</a:t>
             </a:r>
           </a:p>
           <a:p>
             <a:pPr lvl="3"/>
             <a:r>
-              <a:rPr lang="ru-RU" smtClean="0"/>
+              <a:rPr lang="ru-RU"/>
               <a:t>Четвертый уровень</a:t>
             </a:r>
           </a:p>
           <a:p>
             <a:pPr lvl="4"/>
             <a:r>
-              <a:rPr lang="ru-RU" smtClean="0"/>
+              <a:rPr lang="ru-RU"/>
               <a:t>Пятый уровень</a:t>
             </a:r>
-            <a:endParaRPr lang="ru-RU"/>
           </a:p>
         </p:txBody>
       </p:sp>
@@ -2194,7 +2193,7 @@
           <a:p>
             <a:pPr lvl="0"/>
             <a:r>
-              <a:rPr lang="ru-RU" smtClean="0"/>
+              <a:rPr lang="ru-RU"/>
               <a:t>Образец текста</a:t>
             </a:r>
           </a:p>
@@ -2217,7 +2216,7 @@
           <a:p>
             <a:fld id="{B4C71EC6-210F-42DE-9C53-41977AD35B3D}" type="datetimeFigureOut">
               <a:rPr lang="ru-RU" smtClean="0"/>
-              <a:t>17.05.2026</a:t>
+              <a:t>05.09.2026</a:t>
             </a:fld>
             <a:endParaRPr lang="ru-RU"/>
           </a:p>
@@ -2315,10 +2314,9 @@
           </a:lstStyle>
           <a:p>
             <a:r>
-              <a:rPr lang="ru-RU" smtClean="0"/>
+              <a:rPr lang="ru-RU"/>
               <a:t>Образец заголовка</a:t>
             </a:r>
-            <a:endParaRPr lang="ru-RU"/>
           </a:p>
         </p:txBody>
       </p:sp>
@@ -2442,7 +2440,7 @@
           <a:p>
             <a:pPr lvl="0"/>
             <a:r>
-              <a:rPr lang="ru-RU" smtClean="0"/>
+              <a:rPr lang="ru-RU"/>
               <a:t>Образец текста</a:t>
             </a:r>
           </a:p>
@@ -2465,7 +2463,7 @@
           <a:p>
             <a:fld id="{B4C71EC6-210F-42DE-9C53-41977AD35B3D}" type="datetimeFigureOut">
               <a:rPr lang="ru-RU" smtClean="0"/>
-              <a:t>17.05.2026</a:t>
+              <a:t>05.09.2026</a:t>
             </a:fld>
             <a:endParaRPr lang="ru-RU"/>
           </a:p>
@@ -2569,10 +2567,9 @@
           <a:lstStyle/>
           <a:p>
             <a:r>
-              <a:rPr lang="ru-RU" smtClean="0"/>
+              <a:rPr lang="ru-RU"/>
               <a:t>Образец заголовка</a:t>
             </a:r>
-            <a:endParaRPr lang="ru-RU"/>
           </a:p>
         </p:txBody>
       </p:sp>
@@ -2603,38 +2600,37 @@
           <a:p>
             <a:pPr lvl="0"/>
             <a:r>
-              <a:rPr lang="ru-RU" smtClean="0"/>
+              <a:rPr lang="ru-RU"/>
               <a:t>Образец текста</a:t>
             </a:r>
           </a:p>
           <a:p>
             <a:pPr lvl="1"/>
             <a:r>
-              <a:rPr lang="ru-RU" smtClean="0"/>
+              <a:rPr lang="ru-RU"/>
               <a:t>Второй уровень</a:t>
             </a:r>
           </a:p>
           <a:p>
             <a:pPr lvl="2"/>
             <a:r>
-              <a:rPr lang="ru-RU" smtClean="0"/>
+              <a:rPr lang="ru-RU"/>
               <a:t>Третий уровень</a:t>
             </a:r>
           </a:p>
           <a:p>
             <a:pPr lvl="3"/>
             <a:r>
-              <a:rPr lang="ru-RU" smtClean="0"/>
+              <a:rPr lang="ru-RU"/>
               <a:t>Четвертый уровень</a:t>
             </a:r>
           </a:p>
           <a:p>
             <a:pPr lvl="4"/>
             <a:r>
-              <a:rPr lang="ru-RU" smtClean="0"/>
+              <a:rPr lang="ru-RU"/>
               <a:t>Пятый уровень</a:t>
             </a:r>
-            <a:endParaRPr lang="ru-RU"/>
           </a:p>
         </p:txBody>
       </p:sp>
@@ -2673,7 +2669,7 @@
           <a:p>
             <a:fld id="{B4C71EC6-210F-42DE-9C53-41977AD35B3D}" type="datetimeFigureOut">
               <a:rPr lang="ru-RU" smtClean="0"/>
-              <a:t>17.05.2026</a:t>
+              <a:t>05.09.2026</a:t>
             </a:fld>
             <a:endParaRPr lang="ru-RU"/>
           </a:p>
@@ -3053,42 +3049,47 @@
             <p:ph type="ctrTitle"/>
           </p:nvPr>
         </p:nvSpPr>
-        <p:spPr/>
+        <p:spPr>
+          <a:xfrm>
+            <a:off x="503548" y="2132856"/>
+            <a:ext cx="8136904" cy="1470025"/>
+          </a:xfrm>
+        </p:spPr>
         <p:txBody>
           <a:bodyPr>
-            <a:normAutofit fontScale="90000"/>
+            <a:noAutofit/>
           </a:bodyPr>
           <a:lstStyle/>
           <a:p>
             <a:r>
-              <a:rPr lang="ru-RU" b="1" dirty="0">
+              <a:rPr lang="ru-RU" sz="3600" b="1" dirty="0">
                 <a:latin typeface="Times New Roman" panose="02020603050405020304" pitchFamily="18" charset="0"/>
                 <a:cs typeface="Times New Roman" panose="02020603050405020304" pitchFamily="18" charset="0"/>
               </a:rPr>
               <a:t>Установка минимального демонстрационного стенда </a:t>
             </a:r>
             <a:r>
-              <a:rPr lang="ru-RU" b="1" dirty="0" err="1">
+              <a:rPr lang="ru-RU" sz="3600" b="1" dirty="0" err="1">
                 <a:latin typeface="Times New Roman" panose="02020603050405020304" pitchFamily="18" charset="0"/>
                 <a:cs typeface="Times New Roman" panose="02020603050405020304" pitchFamily="18" charset="0"/>
               </a:rPr>
               <a:t>MooseFS</a:t>
             </a:r>
             <a:r>
-              <a:rPr lang="ru-RU" b="1" dirty="0">
+              <a:rPr lang="ru-RU" sz="3600" b="1" dirty="0">
                 <a:latin typeface="Times New Roman" panose="02020603050405020304" pitchFamily="18" charset="0"/>
                 <a:cs typeface="Times New Roman" panose="02020603050405020304" pitchFamily="18" charset="0"/>
               </a:rPr>
               <a:t> (мультинодовый </a:t>
             </a:r>
             <a:r>
-              <a:rPr lang="ru-RU" b="1" dirty="0" err="1">
+              <a:rPr lang="ru-RU" sz="3600" b="1" dirty="0" err="1">
                 <a:latin typeface="Times New Roman" panose="02020603050405020304" pitchFamily="18" charset="0"/>
                 <a:cs typeface="Times New Roman" panose="02020603050405020304" pitchFamily="18" charset="0"/>
               </a:rPr>
               <a:t>режим)</a:t>
             </a:r>
-            <a:endParaRPr lang="ru-RU" b="1" dirty="0">
+            <a:endParaRPr lang="ru-RU" sz="3600" b="1" dirty="0">
               <a:latin typeface="Times New Roman" panose="02020603050405020304" pitchFamily="18" charset="0"/>
               <a:cs typeface="Times New Roman" panose="02020603050405020304" pitchFamily="18" charset="0"/>
             </a:endParaRPr>
@@ -3107,8 +3108,8 @@
         </p:nvSpPr>
         <p:spPr>
           <a:xfrm>
-            <a:off x="467544" y="4412704"/>
-            <a:ext cx="8136904" cy="1752600"/>
+            <a:off x="503548" y="4791694"/>
+            <a:ext cx="8136904" cy="1470026"/>
           </a:xfrm>
         </p:spPr>
         <p:txBody>
@@ -3126,25 +3127,8 @@
                 <a:latin typeface="Times New Roman" panose="02020603050405020304" pitchFamily="18" charset="0"/>
                 <a:cs typeface="Times New Roman" panose="02020603050405020304" pitchFamily="18" charset="0"/>
               </a:rPr>
-              <a:t>Выполнил: Ильин </a:t>
-            </a:r>
-            <a:r>
-              <a:rPr lang="ru-RU" sz="2000" dirty="0" smtClean="0">
-                <a:solidFill>
-                  <a:schemeClr val="tx1"/>
-                </a:solidFill>
-                <a:latin typeface="Times New Roman" panose="02020603050405020304" pitchFamily="18" charset="0"/>
-                <a:cs typeface="Times New Roman" panose="02020603050405020304" pitchFamily="18" charset="0"/>
-              </a:rPr>
-              <a:t>Николай АСУ8-25-1М</a:t>
-            </a:r>
-            <a:endParaRPr lang="ru-RU" sz="2000" dirty="0">
-              <a:solidFill>
-                <a:schemeClr val="tx1"/>
-              </a:solidFill>
-              <a:latin typeface="Times New Roman" panose="02020603050405020304" pitchFamily="18" charset="0"/>
-              <a:cs typeface="Times New Roman" panose="02020603050405020304" pitchFamily="18" charset="0"/>
-            </a:endParaRPr>
+              <a:t>Выполнил: Ильин Николай АСУ8-25-1М</a:t>
+            </a:r>
           </a:p>
         </p:txBody>
       </p:sp>
@@ -3171,7 +3155,7 @@
           <a:p>
             <a:pPr algn="ctr"/>
             <a:r>
-              <a:rPr lang="en-US" dirty="0" smtClean="0">
+              <a:rPr lang="en-US" dirty="0">
                 <a:latin typeface="Times New Roman" panose="02020603050405020304" pitchFamily="18" charset="0"/>
                 <a:cs typeface="Times New Roman" panose="02020603050405020304" pitchFamily="18" charset="0"/>
               </a:rPr>
@@ -3194,13 +3178,377 @@
   <p:clrMapOvr>
     <a:masterClrMapping/>
   </p:clrMapOvr>
-  <p:timing>
-    <p:tnLst>
-      <p:par>
-        <p:cTn id="1" dur="indefinite" restart="never" nodeType="tmRoot"/>
-      </p:par>
-    </p:tnLst>
-  </p:timing>
+</p:sld>
+</file>
+
+<file path=ppt/slides/slide10.xml><?xml version="1.0" encoding="utf-8"?>
+<p:sld xmlns:a="http://schemas.openxmlformats.org/drawingml/2006/main" xmlns:r="http://schemas.openxmlformats.org/officeDocument/2006/relationships" xmlns:p="http://schemas.openxmlformats.org/presentationml/2006/main">
+  <p:cSld>
+    <p:spTree>
+      <p:nvGrpSpPr>
+        <p:cNvPr id="1" name=""/>
+        <p:cNvGrpSpPr/>
+        <p:nvPr/>
+      </p:nvGrpSpPr>
+      <p:grpSpPr>
+        <a:xfrm>
+          <a:off x="0" y="0"/>
+          <a:ext cx="0" cy="0"/>
+          <a:chOff x="0" y="0"/>
+          <a:chExt cx="0" cy="0"/>
+        </a:xfrm>
+      </p:grpSpPr>
+      <p:sp>
+        <p:nvSpPr>
+          <p:cNvPr id="2" name="Заголовок 1"/>
+          <p:cNvSpPr>
+            <a:spLocks noGrp="1"/>
+          </p:cNvSpPr>
+          <p:nvPr>
+            <p:ph type="title"/>
+          </p:nvPr>
+        </p:nvSpPr>
+        <p:spPr>
+          <a:xfrm>
+            <a:off x="457200" y="188640"/>
+            <a:ext cx="8229600" cy="1143000"/>
+          </a:xfrm>
+        </p:spPr>
+        <p:txBody>
+          <a:bodyPr>
+            <a:noAutofit/>
+          </a:bodyPr>
+          <a:lstStyle/>
+          <a:p>
+            <a:r>
+              <a:rPr lang="ru-RU" sz="3200" b="1" dirty="0">
+                <a:latin typeface="Times New Roman" panose="02020603050405020304" pitchFamily="18" charset="0"/>
+                <a:cs typeface="Times New Roman" panose="02020603050405020304" pitchFamily="18" charset="0"/>
+              </a:rPr>
+              <a:t>Заключение</a:t>
+            </a:r>
+          </a:p>
+        </p:txBody>
+      </p:sp>
+      <p:sp>
+        <p:nvSpPr>
+          <p:cNvPr id="3" name="Объект 2"/>
+          <p:cNvSpPr>
+            <a:spLocks noGrp="1"/>
+          </p:cNvSpPr>
+          <p:nvPr>
+            <p:ph idx="1"/>
+          </p:nvPr>
+        </p:nvSpPr>
+        <p:spPr>
+          <a:xfrm>
+            <a:off x="323528" y="1268760"/>
+            <a:ext cx="8496944" cy="5328592"/>
+          </a:xfrm>
+        </p:spPr>
+        <p:txBody>
+          <a:bodyPr>
+            <a:normAutofit fontScale="92500" lnSpcReduction="10000"/>
+          </a:bodyPr>
+          <a:lstStyle/>
+          <a:p>
+            <a:pPr marL="0" indent="0" algn="just">
+              <a:buNone/>
+            </a:pPr>
+            <a:r>
+              <a:rPr lang="ru-RU" sz="1800" b="1" dirty="0">
+                <a:latin typeface="Times New Roman" panose="02020603050405020304" pitchFamily="18" charset="0"/>
+                <a:cs typeface="Times New Roman" panose="02020603050405020304" pitchFamily="18" charset="0"/>
+              </a:rPr>
+              <a:t>Подтвержденные возможности:</a:t>
+            </a:r>
+          </a:p>
+          <a:p>
+            <a:pPr marL="0" indent="0" algn="just">
+              <a:buNone/>
+            </a:pPr>
+            <a:endParaRPr lang="ru-RU" sz="1800" b="1" dirty="0">
+              <a:latin typeface="Times New Roman" panose="02020603050405020304" pitchFamily="18" charset="0"/>
+              <a:cs typeface="Times New Roman" panose="02020603050405020304" pitchFamily="18" charset="0"/>
+            </a:endParaRPr>
+          </a:p>
+          <a:p>
+            <a:pPr algn="just"/>
+            <a:r>
+              <a:rPr lang="ru-RU" sz="1800" b="1" dirty="0">
+                <a:latin typeface="Times New Roman" panose="02020603050405020304" pitchFamily="18" charset="0"/>
+                <a:cs typeface="Times New Roman" panose="02020603050405020304" pitchFamily="18" charset="0"/>
+              </a:rPr>
+              <a:t>Единое пространство имён — клиент видит один раздел /mnt/mfs</a:t>
+            </a:r>
+            <a:r>
+              <a:rPr lang="ru-RU" sz="1800" dirty="0">
+                <a:latin typeface="Times New Roman" panose="02020603050405020304" pitchFamily="18" charset="0"/>
+                <a:cs typeface="Times New Roman" panose="02020603050405020304" pitchFamily="18" charset="0"/>
+              </a:rPr>
+              <a:t>,</a:t>
+            </a:r>
+            <a:r>
+              <a:rPr lang="ru-RU" sz="1800" b="1" dirty="0">
+                <a:latin typeface="Times New Roman" panose="02020603050405020304" pitchFamily="18" charset="0"/>
+                <a:cs typeface="Times New Roman" panose="02020603050405020304" pitchFamily="18" charset="0"/>
+              </a:rPr>
+              <a:t> </a:t>
+            </a:r>
+            <a:r>
+              <a:rPr lang="ru-RU" sz="1800" dirty="0" err="1">
+                <a:latin typeface="Times New Roman" panose="02020603050405020304" pitchFamily="18" charset="0"/>
+                <a:cs typeface="Times New Roman" panose="02020603050405020304" pitchFamily="18" charset="0"/>
+              </a:rPr>
+              <a:t>MooseFS</a:t>
+            </a:r>
+            <a:r>
+              <a:rPr lang="ru-RU" sz="1800" dirty="0">
+                <a:latin typeface="Times New Roman" panose="02020603050405020304" pitchFamily="18" charset="0"/>
+                <a:cs typeface="Times New Roman" panose="02020603050405020304" pitchFamily="18" charset="0"/>
+              </a:rPr>
+              <a:t> распределённый по трём chunk-серверам.</a:t>
+            </a:r>
+          </a:p>
+          <a:p>
+            <a:pPr algn="just"/>
+            <a:r>
+              <a:rPr lang="ru-RU" sz="1800" b="1" dirty="0">
+                <a:latin typeface="Times New Roman" panose="02020603050405020304" pitchFamily="18" charset="0"/>
+                <a:cs typeface="Times New Roman" panose="02020603050405020304" pitchFamily="18" charset="0"/>
+              </a:rPr>
+              <a:t>Репликация </a:t>
+            </a:r>
+            <a:r>
+              <a:rPr lang="ru-RU" sz="1800" dirty="0">
+                <a:latin typeface="Times New Roman" panose="02020603050405020304" pitchFamily="18" charset="0"/>
+                <a:cs typeface="Times New Roman" panose="02020603050405020304" pitchFamily="18" charset="0"/>
+              </a:rPr>
+              <a:t>— класс 3CP хранит по 3 копии каждого chunk'а на 3 разных узлах.</a:t>
+            </a:r>
+          </a:p>
+          <a:p>
+            <a:pPr algn="just"/>
+            <a:r>
+              <a:rPr lang="ru-RU" sz="1800" b="1" dirty="0">
+                <a:latin typeface="Times New Roman" panose="02020603050405020304" pitchFamily="18" charset="0"/>
+                <a:cs typeface="Times New Roman" panose="02020603050405020304" pitchFamily="18" charset="0"/>
+              </a:rPr>
+              <a:t>Разбиение </a:t>
+            </a:r>
+            <a:r>
+              <a:rPr lang="ru-RU" sz="1800" b="1" dirty="0" err="1">
+                <a:latin typeface="Times New Roman" panose="02020603050405020304" pitchFamily="18" charset="0"/>
+                <a:cs typeface="Times New Roman" panose="02020603050405020304" pitchFamily="18" charset="0"/>
+              </a:rPr>
+              <a:t>на chunk'ы</a:t>
+            </a:r>
+            <a:r>
+              <a:rPr lang="ru-RU" sz="1800" b="1" dirty="0">
+                <a:latin typeface="Times New Roman" panose="02020603050405020304" pitchFamily="18" charset="0"/>
+                <a:cs typeface="Times New Roman" panose="02020603050405020304" pitchFamily="18" charset="0"/>
+              </a:rPr>
+              <a:t> </a:t>
+            </a:r>
+            <a:r>
+              <a:rPr lang="ru-RU" sz="1800" dirty="0">
+                <a:latin typeface="Times New Roman" panose="02020603050405020304" pitchFamily="18" charset="0"/>
+                <a:cs typeface="Times New Roman" panose="02020603050405020304" pitchFamily="18" charset="0"/>
+              </a:rPr>
+              <a:t>— файл 100 МБ разбит на 2 chunk'а (64 + 36), каждый реплицируется отдельно </a:t>
+            </a:r>
+            <a:r>
+              <a:rPr lang="ru-RU" sz="1800" dirty="0" err="1">
+                <a:latin typeface="Times New Roman" panose="02020603050405020304" pitchFamily="18" charset="0"/>
+                <a:cs typeface="Times New Roman" panose="02020603050405020304" pitchFamily="18" charset="0"/>
+              </a:rPr>
+              <a:t>(mfsfileinfo)</a:t>
+            </a:r>
+            <a:r>
+              <a:rPr lang="ru-RU" sz="1800" dirty="0">
+                <a:latin typeface="Times New Roman" panose="02020603050405020304" pitchFamily="18" charset="0"/>
+                <a:cs typeface="Times New Roman" panose="02020603050405020304" pitchFamily="18" charset="0"/>
+              </a:rPr>
+              <a:t>.</a:t>
+            </a:r>
+          </a:p>
+          <a:p>
+            <a:pPr algn="just"/>
+            <a:r>
+              <a:rPr lang="ru-RU" sz="1800" b="1" dirty="0">
+                <a:latin typeface="Times New Roman" panose="02020603050405020304" pitchFamily="18" charset="0"/>
+                <a:cs typeface="Times New Roman" panose="02020603050405020304" pitchFamily="18" charset="0"/>
+              </a:rPr>
+              <a:t>Отказоустойчивость N−1 </a:t>
+            </a:r>
+            <a:r>
+              <a:rPr lang="ru-RU" sz="1800" dirty="0">
+                <a:latin typeface="Times New Roman" panose="02020603050405020304" pitchFamily="18" charset="0"/>
+                <a:cs typeface="Times New Roman" panose="02020603050405020304" pitchFamily="18" charset="0"/>
+              </a:rPr>
+              <a:t>— при остановке </a:t>
+            </a:r>
+            <a:r>
+              <a:rPr lang="ru-RU" sz="1800" dirty="0" err="1">
+                <a:latin typeface="Times New Roman" panose="02020603050405020304" pitchFamily="18" charset="0"/>
+                <a:cs typeface="Times New Roman" panose="02020603050405020304" pitchFamily="18" charset="0"/>
+              </a:rPr>
+              <a:t>одного</a:t>
+            </a:r>
+            <a:r>
+              <a:rPr lang="ru-RU" sz="1800" dirty="0">
+                <a:latin typeface="Times New Roman" panose="02020603050405020304" pitchFamily="18" charset="0"/>
+                <a:cs typeface="Times New Roman" panose="02020603050405020304" pitchFamily="18" charset="0"/>
+              </a:rPr>
+              <a:t> chunk-сервера md5sum 100 МБ файла возвращает корректные данные с оставшихся копий.</a:t>
+            </a:r>
+          </a:p>
+          <a:p>
+            <a:pPr algn="just"/>
+            <a:r>
+              <a:rPr lang="ru-RU" sz="1800" b="1" dirty="0">
+                <a:latin typeface="Times New Roman" panose="02020603050405020304" pitchFamily="18" charset="0"/>
+                <a:cs typeface="Times New Roman" panose="02020603050405020304" pitchFamily="18" charset="0"/>
+              </a:rPr>
+              <a:t>Самовосстановление </a:t>
+            </a:r>
+            <a:r>
+              <a:rPr lang="ru-RU" sz="1800" dirty="0">
+                <a:latin typeface="Times New Roman" panose="02020603050405020304" pitchFamily="18" charset="0"/>
+                <a:cs typeface="Times New Roman" panose="02020603050405020304" pitchFamily="18" charset="0"/>
+              </a:rPr>
+              <a:t>— после возврата узла мастер запускает replication jobs и восстанавливает копии.</a:t>
+            </a:r>
+          </a:p>
+          <a:p>
+            <a:pPr algn="just"/>
+            <a:r>
+              <a:rPr lang="ru-RU" sz="1800" b="1" dirty="0">
+                <a:latin typeface="Times New Roman" panose="02020603050405020304" pitchFamily="18" charset="0"/>
+                <a:cs typeface="Times New Roman" panose="02020603050405020304" pitchFamily="18" charset="0"/>
+              </a:rPr>
+              <a:t>Резервирование метаданных </a:t>
+            </a:r>
+            <a:r>
+              <a:rPr lang="ru-RU" sz="1800" dirty="0">
+                <a:latin typeface="Times New Roman" panose="02020603050405020304" pitchFamily="18" charset="0"/>
+                <a:cs typeface="Times New Roman" panose="02020603050405020304" pitchFamily="18" charset="0"/>
+              </a:rPr>
+              <a:t>— metalogger </a:t>
+            </a:r>
+            <a:r>
+              <a:rPr lang="ru-RU" sz="1800" dirty="0" err="1">
+                <a:latin typeface="Times New Roman" panose="02020603050405020304" pitchFamily="18" charset="0"/>
+                <a:cs typeface="Times New Roman" panose="02020603050405020304" pitchFamily="18" charset="0"/>
+              </a:rPr>
+              <a:t>MooseFS</a:t>
+            </a:r>
+            <a:r>
+              <a:rPr lang="ru-RU" sz="1800" dirty="0">
+                <a:latin typeface="Times New Roman" panose="02020603050405020304" pitchFamily="18" charset="0"/>
+                <a:cs typeface="Times New Roman" panose="02020603050405020304" pitchFamily="18" charset="0"/>
+              </a:rPr>
+              <a:t> непрерывно тянет с мастера журнал изменений metadata.mfs.</a:t>
+            </a:r>
+          </a:p>
+          <a:p>
+            <a:pPr algn="just"/>
+            <a:r>
+              <a:rPr lang="ru-RU" sz="1800" b="1" dirty="0">
+                <a:latin typeface="Times New Roman" panose="02020603050405020304" pitchFamily="18" charset="0"/>
+                <a:cs typeface="Times New Roman" panose="02020603050405020304" pitchFamily="18" charset="0"/>
+              </a:rPr>
+              <a:t>Мониторинг </a:t>
+            </a:r>
+            <a:r>
+              <a:rPr lang="ru-RU" sz="1800" dirty="0">
+                <a:latin typeface="Times New Roman" panose="02020603050405020304" pitchFamily="18" charset="0"/>
+                <a:cs typeface="Times New Roman" panose="02020603050405020304" pitchFamily="18" charset="0"/>
+              </a:rPr>
+              <a:t>— штатные утилиты </a:t>
+            </a:r>
+            <a:r>
+              <a:rPr lang="ru-RU" sz="1800" dirty="0" err="1">
+                <a:latin typeface="Times New Roman" panose="02020603050405020304" pitchFamily="18" charset="0"/>
+                <a:cs typeface="Times New Roman" panose="02020603050405020304" pitchFamily="18" charset="0"/>
+              </a:rPr>
+              <a:t>MooseFS 4</a:t>
+            </a:r>
+            <a:r>
+              <a:rPr lang="ru-RU" sz="1800" dirty="0">
+                <a:latin typeface="Times New Roman" panose="02020603050405020304" pitchFamily="18" charset="0"/>
+                <a:cs typeface="Times New Roman" panose="02020603050405020304" pitchFamily="18" charset="0"/>
+              </a:rPr>
+              <a:t>: mfsfileinfo, mfscheckfile, mfsdirinfo, mfsgetsclass -r и docker logs.</a:t>
+            </a:r>
+          </a:p>
+          <a:p>
+            <a:pPr marL="0" indent="0" algn="just">
+              <a:buNone/>
+            </a:pPr>
+            <a:endParaRPr lang="ru-RU" sz="1800" b="1" dirty="0">
+              <a:latin typeface="Times New Roman" panose="02020603050405020304" pitchFamily="18" charset="0"/>
+              <a:cs typeface="Times New Roman" panose="02020603050405020304" pitchFamily="18" charset="0"/>
+            </a:endParaRPr>
+          </a:p>
+          <a:p>
+            <a:pPr marL="0" indent="0" algn="just">
+              <a:buNone/>
+            </a:pPr>
+            <a:r>
+              <a:rPr lang="ru-RU" sz="1800" dirty="0">
+                <a:latin typeface="Times New Roman" panose="02020603050405020304" pitchFamily="18" charset="0"/>
+                <a:cs typeface="Times New Roman" panose="02020603050405020304" pitchFamily="18" charset="0"/>
+              </a:rPr>
+              <a:t>       Стенд </a:t>
+            </a:r>
+            <a:r>
+              <a:rPr lang="ru-RU" sz="1800" dirty="0" err="1">
+                <a:latin typeface="Times New Roman" panose="02020603050405020304" pitchFamily="18" charset="0"/>
+                <a:cs typeface="Times New Roman" panose="02020603050405020304" pitchFamily="18" charset="0"/>
+              </a:rPr>
+              <a:t>MooseFS</a:t>
+            </a:r>
+            <a:r>
+              <a:rPr lang="ru-RU" sz="1800" dirty="0">
+                <a:latin typeface="Times New Roman" panose="02020603050405020304" pitchFamily="18" charset="0"/>
+                <a:cs typeface="Times New Roman" panose="02020603050405020304" pitchFamily="18" charset="0"/>
+              </a:rPr>
+              <a:t> в мультинодовом режиме </a:t>
+            </a:r>
+            <a:r>
+              <a:rPr lang="ru-RU" sz="1800" dirty="0" err="1">
+                <a:latin typeface="Times New Roman" panose="02020603050405020304" pitchFamily="18" charset="0"/>
+                <a:cs typeface="Times New Roman" panose="02020603050405020304" pitchFamily="18" charset="0"/>
+              </a:rPr>
+              <a:t>(Docker Compose)</a:t>
+            </a:r>
+            <a:r>
+              <a:rPr lang="ru-RU" sz="1800" dirty="0">
+                <a:latin typeface="Times New Roman" panose="02020603050405020304" pitchFamily="18" charset="0"/>
+                <a:cs typeface="Times New Roman" panose="02020603050405020304" pitchFamily="18" charset="0"/>
+              </a:rPr>
+              <a:t> полностью работоспособен и демонстрирует ключевые свойства распределённой файловой системы: горизонтальное масштабирование хранилища, прозрачную репликацию chunk'ов и устойчивость к отказу отдельных узлов. Все тесты пройдены успешно.</a:t>
+            </a:r>
+          </a:p>
+          <a:p>
+            <a:pPr marL="0" indent="0" algn="just">
+              <a:buNone/>
+            </a:pPr>
+            <a:endParaRPr lang="ru-RU" sz="2800" dirty="0"/>
+          </a:p>
+        </p:txBody>
+      </p:sp>
+    </p:spTree>
+    <p:extLst>
+      <p:ext uri="{BB962C8B-B14F-4D97-AF65-F5344CB8AC3E}">
+        <p14:creationId xmlns:p14="http://schemas.microsoft.com/office/powerpoint/2010/main" val="3987295580"/>
+      </p:ext>
+    </p:extLst>
+  </p:cSld>
+  <p:clrMapOvr>
+    <a:masterClrMapping/>
+  </p:clrMapOvr>
 </p:sld>
 </file>
 
@@ -3233,11 +3581,13 @@
         </p:nvSpPr>
         <p:spPr/>
         <p:txBody>
-          <a:bodyPr/>
-          <a:lstStyle/>
-          <a:p>
-            <a:r>
-              <a:rPr lang="ru-RU" b="1" dirty="0">
+          <a:bodyPr>
+            <a:normAutofit/>
+          </a:bodyPr>
+          <a:lstStyle/>
+          <a:p>
+            <a:r>
+              <a:rPr lang="ru-RU" sz="4000" b="1" dirty="0">
                 <a:latin typeface="Times New Roman" panose="02020603050405020304" pitchFamily="18" charset="0"/>
                 <a:cs typeface="Times New Roman" panose="02020603050405020304" pitchFamily="18" charset="0"/>
               </a:rPr>
@@ -3256,7 +3606,12 @@
             <p:ph idx="1"/>
           </p:nvPr>
         </p:nvSpPr>
-        <p:spPr/>
+        <p:spPr>
+          <a:xfrm>
+            <a:off x="457200" y="1772816"/>
+            <a:ext cx="8229600" cy="4525963"/>
+          </a:xfrm>
+        </p:spPr>
         <p:txBody>
           <a:bodyPr>
             <a:normAutofit/>
@@ -3354,19 +3709,8 @@
                 <a:latin typeface="Times New Roman" panose="02020603050405020304" pitchFamily="18" charset="0"/>
                 <a:cs typeface="Times New Roman" panose="02020603050405020304" pitchFamily="18" charset="0"/>
               </a:rPr>
-              <a:t>Проверить самовосстановление реплик после возврата </a:t>
-            </a:r>
-            <a:r>
-              <a:rPr lang="ru-RU" sz="2400" dirty="0" smtClean="0">
-                <a:latin typeface="Times New Roman" panose="02020603050405020304" pitchFamily="18" charset="0"/>
-                <a:cs typeface="Times New Roman" panose="02020603050405020304" pitchFamily="18" charset="0"/>
-              </a:rPr>
-              <a:t>узла</a:t>
-            </a:r>
-            <a:endParaRPr lang="ru-RU" sz="2400" dirty="0">
-              <a:latin typeface="Times New Roman" panose="02020603050405020304" pitchFamily="18" charset="0"/>
-              <a:cs typeface="Times New Roman" panose="02020603050405020304" pitchFamily="18" charset="0"/>
-            </a:endParaRPr>
+              <a:t>Проверить самовосстановление реплик после возврата узла</a:t>
+            </a:r>
           </a:p>
         </p:txBody>
       </p:sp>
@@ -3380,13 +3724,6 @@
   <p:clrMapOvr>
     <a:masterClrMapping/>
   </p:clrMapOvr>
-  <p:timing>
-    <p:tnLst>
-      <p:par>
-        <p:cTn id="1" dur="indefinite" restart="never" nodeType="tmRoot"/>
-      </p:par>
-    </p:tnLst>
-  </p:timing>
 </p:sld>
 </file>
 
@@ -3441,23 +3778,41 @@
           <p:nvPr>
             <p:extLst>
               <p:ext uri="{D42A27DB-BD31-4B8C-83A1-F6EECF244321}">
-                <p14:modId xmlns:p14="http://schemas.microsoft.com/office/powerpoint/2010/main" val="1315564066"/>
+                <p14:modId xmlns:p14="http://schemas.microsoft.com/office/powerpoint/2010/main" val="2542631310"/>
               </p:ext>
             </p:extLst>
           </p:nvPr>
         </p:nvGraphicFramePr>
         <p:xfrm>
-          <a:off x="1115616" y="1844824"/>
-          <a:ext cx="7162800" cy="3421380"/>
+          <a:off x="971600" y="1844824"/>
+          <a:ext cx="7306815" cy="3147060"/>
         </p:xfrm>
         <a:graphic>
           <a:graphicData uri="http://schemas.openxmlformats.org/drawingml/2006/table">
             <a:tbl>
               <a:tblPr/>
               <a:tblGrid>
-                <a:gridCol w="2387600"/>
-                <a:gridCol w="2387600"/>
-                <a:gridCol w="2387600"/>
+                <a:gridCol w="2435605">
+                  <a:extLst>
+                    <a:ext uri="{9D8B030D-6E8A-4147-A177-3AD203B41FA5}">
+                      <a16:colId xmlns:a16="http://schemas.microsoft.com/office/drawing/2014/main" val="20000"/>
+                    </a:ext>
+                  </a:extLst>
+                </a:gridCol>
+                <a:gridCol w="2435605">
+                  <a:extLst>
+                    <a:ext uri="{9D8B030D-6E8A-4147-A177-3AD203B41FA5}">
+                      <a16:colId xmlns:a16="http://schemas.microsoft.com/office/drawing/2014/main" val="20001"/>
+                    </a:ext>
+                  </a:extLst>
+                </a:gridCol>
+                <a:gridCol w="2435605">
+                  <a:extLst>
+                    <a:ext uri="{9D8B030D-6E8A-4147-A177-3AD203B41FA5}">
+                      <a16:colId xmlns:a16="http://schemas.microsoft.com/office/drawing/2014/main" val="20002"/>
+                    </a:ext>
+                  </a:extLst>
+                </a:gridCol>
               </a:tblGrid>
               <a:tr h="0">
                 <a:tc>
@@ -3465,7 +3820,7 @@
                     <a:bodyPr/>
                     <a:lstStyle/>
                     <a:p>
-                      <a:pPr algn="l"/>
+                      <a:pPr algn="ctr"/>
                       <a:r>
                         <a:rPr lang="ru-RU" b="0" dirty="0">
                           <a:effectLst/>
@@ -3496,7 +3851,7 @@
                     <a:bodyPr/>
                     <a:lstStyle/>
                     <a:p>
-                      <a:pPr algn="l"/>
+                      <a:pPr algn="ctr"/>
                       <a:r>
                         <a:rPr lang="ru-RU" b="0" dirty="0">
                           <a:effectLst/>
@@ -3527,7 +3882,7 @@
                     <a:bodyPr/>
                     <a:lstStyle/>
                     <a:p>
-                      <a:pPr algn="l"/>
+                      <a:pPr algn="ctr"/>
                       <a:r>
                         <a:rPr lang="ru-RU" b="0" dirty="0">
                           <a:effectLst/>
@@ -3553,6 +3908,11 @@
                     </a:lnB>
                   </a:tcPr>
                 </a:tc>
+                <a:extLst>
+                  <a:ext uri="{0D108BD9-81ED-4DB2-BD59-A6C34878D82A}">
+                    <a16:rowId xmlns:a16="http://schemas.microsoft.com/office/drawing/2014/main" val="10000"/>
+                  </a:ext>
+                </a:extLst>
               </a:tr>
               <a:tr h="0">
                 <a:tc>
@@ -3560,6 +3920,7 @@
                     <a:bodyPr/>
                     <a:lstStyle/>
                     <a:p>
+                      <a:pPr algn="ctr"/>
                       <a:r>
                         <a:rPr lang="en-US" b="0" dirty="0">
                           <a:effectLst/>
@@ -3590,8 +3951,9 @@
                     <a:bodyPr/>
                     <a:lstStyle/>
                     <a:p>
+                      <a:pPr algn="ctr"/>
                       <a:r>
-                        <a:rPr lang="ru-RU" b="0">
+                        <a:rPr lang="ru-RU" b="0" dirty="0">
                           <a:effectLst/>
                           <a:latin typeface="Times New Roman" panose="02020603050405020304" pitchFamily="18" charset="0"/>
                           <a:cs typeface="Times New Roman" panose="02020603050405020304" pitchFamily="18" charset="0"/>
@@ -3620,6 +3982,7 @@
                     <a:bodyPr/>
                     <a:lstStyle/>
                     <a:p>
+                      <a:pPr algn="ctr"/>
                       <a:r>
                         <a:rPr lang="ru-RU" b="0" dirty="0">
                           <a:effectLst/>
@@ -3645,6 +4008,11 @@
                     </a:lnB>
                   </a:tcPr>
                 </a:tc>
+                <a:extLst>
+                  <a:ext uri="{0D108BD9-81ED-4DB2-BD59-A6C34878D82A}">
+                    <a16:rowId xmlns:a16="http://schemas.microsoft.com/office/drawing/2014/main" val="10001"/>
+                  </a:ext>
+                </a:extLst>
               </a:tr>
               <a:tr h="0">
                 <a:tc>
@@ -3652,6 +4020,7 @@
                     <a:bodyPr/>
                     <a:lstStyle/>
                     <a:p>
+                      <a:pPr algn="ctr"/>
                       <a:r>
                         <a:rPr lang="en-US" b="0" dirty="0" err="1">
                           <a:effectLst/>
@@ -3687,6 +4056,7 @@
                     <a:bodyPr/>
                     <a:lstStyle/>
                     <a:p>
+                      <a:pPr algn="ctr"/>
                       <a:r>
                         <a:rPr lang="ru-RU" b="0" dirty="0">
                           <a:effectLst/>
@@ -3717,8 +4087,9 @@
                     <a:bodyPr/>
                     <a:lstStyle/>
                     <a:p>
+                      <a:pPr algn="ctr"/>
                       <a:r>
-                        <a:rPr lang="ru-RU" b="0">
+                        <a:rPr lang="ru-RU" b="0" dirty="0">
                           <a:effectLst/>
                           <a:latin typeface="Times New Roman" panose="02020603050405020304" pitchFamily="18" charset="0"/>
                           <a:cs typeface="Times New Roman" panose="02020603050405020304" pitchFamily="18" charset="0"/>
@@ -3742,6 +4113,11 @@
                     </a:lnB>
                   </a:tcPr>
                 </a:tc>
+                <a:extLst>
+                  <a:ext uri="{0D108BD9-81ED-4DB2-BD59-A6C34878D82A}">
+                    <a16:rowId xmlns:a16="http://schemas.microsoft.com/office/drawing/2014/main" val="10002"/>
+                  </a:ext>
+                </a:extLst>
               </a:tr>
               <a:tr h="0">
                 <a:tc>
@@ -3749,6 +4125,7 @@
                     <a:bodyPr/>
                     <a:lstStyle/>
                     <a:p>
+                      <a:pPr algn="ctr"/>
                       <a:r>
                         <a:rPr lang="en-US" b="0">
                           <a:effectLst/>
@@ -3779,6 +4156,7 @@
                     <a:bodyPr/>
                     <a:lstStyle/>
                     <a:p>
+                      <a:pPr algn="ctr"/>
                       <a:r>
                         <a:rPr lang="ru-RU" b="0" dirty="0">
                           <a:effectLst/>
@@ -3809,6 +4187,7 @@
                     <a:bodyPr/>
                     <a:lstStyle/>
                     <a:p>
+                      <a:pPr algn="ctr"/>
                       <a:r>
                         <a:rPr lang="ru-RU" b="0" dirty="0">
                           <a:effectLst/>
@@ -3834,6 +4213,11 @@
                     </a:lnB>
                   </a:tcPr>
                 </a:tc>
+                <a:extLst>
+                  <a:ext uri="{0D108BD9-81ED-4DB2-BD59-A6C34878D82A}">
+                    <a16:rowId xmlns:a16="http://schemas.microsoft.com/office/drawing/2014/main" val="10003"/>
+                  </a:ext>
+                </a:extLst>
               </a:tr>
               <a:tr h="0">
                 <a:tc>
@@ -3841,6 +4225,7 @@
                     <a:bodyPr/>
                     <a:lstStyle/>
                     <a:p>
+                      <a:pPr algn="ctr"/>
                       <a:r>
                         <a:rPr lang="en-US" b="0" dirty="0" err="1">
                           <a:effectLst/>
@@ -3876,8 +4261,9 @@
                     <a:bodyPr/>
                     <a:lstStyle/>
                     <a:p>
+                      <a:pPr algn="ctr"/>
                       <a:r>
-                        <a:rPr lang="ru-RU" b="0">
+                        <a:rPr lang="ru-RU" b="0" dirty="0">
                           <a:effectLst/>
                           <a:latin typeface="Times New Roman" panose="02020603050405020304" pitchFamily="18" charset="0"/>
                           <a:cs typeface="Times New Roman" panose="02020603050405020304" pitchFamily="18" charset="0"/>
@@ -3906,6 +4292,7 @@
                     <a:bodyPr/>
                     <a:lstStyle/>
                     <a:p>
+                      <a:pPr algn="ctr"/>
                       <a:r>
                         <a:rPr lang="ru-RU" b="0" dirty="0" err="1">
                           <a:effectLst/>
@@ -3939,6 +4326,11 @@
                     </a:lnB>
                   </a:tcPr>
                 </a:tc>
+                <a:extLst>
+                  <a:ext uri="{0D108BD9-81ED-4DB2-BD59-A6C34878D82A}">
+                    <a16:rowId xmlns:a16="http://schemas.microsoft.com/office/drawing/2014/main" val="10004"/>
+                  </a:ext>
+                </a:extLst>
               </a:tr>
             </a:tbl>
           </a:graphicData>
@@ -3954,13 +4346,6 @@
   <p:clrMapOvr>
     <a:masterClrMapping/>
   </p:clrMapOvr>
-  <p:timing>
-    <p:tnLst>
-      <p:par>
-        <p:cTn id="1" dur="indefinite" restart="never" nodeType="tmRoot"/>
-      </p:par>
-    </p:tnLst>
-  </p:timing>
 </p:sld>
 </file>
 
@@ -3999,45 +4384,30 @@
           <a:lstStyle/>
           <a:p>
             <a:r>
-              <a:rPr lang="ru-RU" sz="3200" b="1" dirty="0" smtClean="0">
+              <a:rPr lang="ru-RU" sz="3200" b="1" dirty="0">
                 <a:latin typeface="Times New Roman" panose="02020603050405020304" pitchFamily="18" charset="0"/>
                 <a:cs typeface="Times New Roman" panose="02020603050405020304" pitchFamily="18" charset="0"/>
               </a:rPr>
               <a:t>Запуск стенда — docker compose ps</a:t>
             </a:r>
-            <a:endParaRPr lang="ru-RU" sz="3200" b="1" dirty="0">
-              <a:latin typeface="Times New Roman" panose="02020603050405020304" pitchFamily="18" charset="0"/>
-              <a:cs typeface="Times New Roman" panose="02020603050405020304" pitchFamily="18" charset="0"/>
-            </a:endParaRPr>
-          </a:p>
-        </p:txBody>
-      </p:sp>
-      <p:sp>
-        <p:nvSpPr>
-          <p:cNvPr id="3" name="Объект 2"/>
-          <p:cNvSpPr>
-            <a:spLocks noGrp="1"/>
-          </p:cNvSpPr>
-          <p:nvPr>
-            <p:ph idx="1"/>
-          </p:nvPr>
-        </p:nvSpPr>
-        <p:spPr/>
-        <p:txBody>
-          <a:bodyPr/>
-          <a:lstStyle/>
-          <a:p>
-            <a:endParaRPr lang="ru-RU" dirty="0"/>
           </a:p>
         </p:txBody>
       </p:sp>
       <p:pic>
         <p:nvPicPr>
-          <p:cNvPr id="2050" name="Picture 2"/>
+          <p:cNvPr id="5" name="Объект 4">
+            <a:extLst>
+              <a:ext uri="{FF2B5EF4-FFF2-40B4-BE49-F238E27FC236}">
+                <a16:creationId xmlns:a16="http://schemas.microsoft.com/office/drawing/2014/main" id="{A1C2D1FA-81E9-B788-3C82-CB2840999142}"/>
+              </a:ext>
+            </a:extLst>
+          </p:cNvPr>
           <p:cNvPicPr>
-            <a:picLocks noChangeAspect="1" noChangeArrowheads="1"/>
+            <a:picLocks noGrp="1" noChangeAspect="1"/>
           </p:cNvPicPr>
-          <p:nvPr/>
+          <p:nvPr>
+            <p:ph idx="1"/>
+          </p:nvPr>
         </p:nvPicPr>
         <p:blipFill>
           <a:blip r:embed="rId2">
@@ -4047,52 +4417,18 @@
               </a:ext>
             </a:extLst>
           </a:blip>
-          <a:srcRect/>
           <a:stretch>
             <a:fillRect/>
           </a:stretch>
         </p:blipFill>
-        <p:spPr bwMode="auto">
+        <p:spPr>
           <a:xfrm>
-            <a:off x="251520" y="2132856"/>
-            <a:ext cx="8622928" cy="2818526"/>
+            <a:off x="53752" y="2708920"/>
+            <a:ext cx="9036496" cy="1846382"/>
           </a:xfrm>
           <a:prstGeom prst="rect">
             <a:avLst/>
           </a:prstGeom>
-          <a:noFill/>
-          <a:ln>
-            <a:noFill/>
-          </a:ln>
-          <a:effectLst/>
-          <a:extLst>
-            <a:ext uri="{909E8E84-426E-40DD-AFC4-6F175D3DCCD1}">
-              <a14:hiddenFill xmlns:a14="http://schemas.microsoft.com/office/drawing/2010/main">
-                <a:solidFill>
-                  <a:schemeClr val="accent1"/>
-                </a:solidFill>
-              </a14:hiddenFill>
-            </a:ext>
-            <a:ext uri="{91240B29-F687-4F45-9708-019B960494DF}">
-              <a14:hiddenLine xmlns:a14="http://schemas.microsoft.com/office/drawing/2010/main" w="9525">
-                <a:solidFill>
-                  <a:schemeClr val="tx1"/>
-                </a:solidFill>
-                <a:miter lim="800000"/>
-                <a:headEnd/>
-                <a:tailEnd/>
-              </a14:hiddenLine>
-            </a:ext>
-            <a:ext uri="{AF507438-7753-43E0-B8FC-AC1667EBCBE1}">
-              <a14:hiddenEffects xmlns:a14="http://schemas.microsoft.com/office/drawing/2010/main">
-                <a:effectLst>
-                  <a:outerShdw dist="35921" dir="2700000" algn="ctr" rotWithShape="0">
-                    <a:schemeClr val="bg2"/>
-                  </a:outerShdw>
-                </a:effectLst>
-              </a14:hiddenEffects>
-            </a:ext>
-          </a:extLst>
         </p:spPr>
       </p:pic>
     </p:spTree>
@@ -4105,13 +4441,6 @@
   <p:clrMapOvr>
     <a:masterClrMapping/>
   </p:clrMapOvr>
-  <p:timing>
-    <p:tnLst>
-      <p:par>
-        <p:cTn id="1" dur="indefinite" restart="never" nodeType="tmRoot"/>
-      </p:par>
-    </p:tnLst>
-  </p:timing>
 </p:sld>
 </file>
 
@@ -4142,7 +4471,12 @@
             <p:ph type="title"/>
           </p:nvPr>
         </p:nvSpPr>
-        <p:spPr/>
+        <p:spPr>
+          <a:xfrm>
+            <a:off x="459594" y="476672"/>
+            <a:ext cx="8229600" cy="1143000"/>
+          </a:xfrm>
+        </p:spPr>
         <p:txBody>
           <a:bodyPr>
             <a:noAutofit/>
@@ -4150,22 +4484,24 @@
           <a:lstStyle/>
           <a:p>
             <a:r>
-              <a:rPr lang="ru-RU" sz="3200" b="1" dirty="0" smtClean="0">
-                <a:latin typeface="Times New Roman" panose="02020603050405020304" pitchFamily="18" charset="0"/>
-                <a:cs typeface="Times New Roman" panose="02020603050405020304" pitchFamily="18" charset="0"/>
-              </a:rPr>
-              <a:t>Клиент видит MFS и доступные storage-классы</a:t>
-            </a:r>
-            <a:endParaRPr lang="ru-RU" sz="3200" b="1" dirty="0">
-              <a:latin typeface="Times New Roman" panose="02020603050405020304" pitchFamily="18" charset="0"/>
-              <a:cs typeface="Times New Roman" panose="02020603050405020304" pitchFamily="18" charset="0"/>
-            </a:endParaRPr>
-          </a:p>
-        </p:txBody>
-      </p:sp>
-      <p:sp>
-        <p:nvSpPr>
-          <p:cNvPr id="3" name="Объект 2"/>
+              <a:rPr lang="ru-RU" sz="3200" b="1" dirty="0">
+                <a:latin typeface="Times New Roman" panose="02020603050405020304" pitchFamily="18" charset="0"/>
+                <a:cs typeface="Times New Roman" panose="02020603050405020304" pitchFamily="18" charset="0"/>
+              </a:rPr>
+              <a:t>Клиент видит MFS</a:t>
+            </a:r>
+          </a:p>
+        </p:txBody>
+      </p:sp>
+      <p:sp>
+        <p:nvSpPr>
+          <p:cNvPr id="13" name="Объект 12">
+            <a:extLst>
+              <a:ext uri="{FF2B5EF4-FFF2-40B4-BE49-F238E27FC236}">
+                <a16:creationId xmlns:a16="http://schemas.microsoft.com/office/drawing/2014/main" id="{96286AAA-7411-14C5-AF19-F4DF2FE9C5FE}"/>
+              </a:ext>
+            </a:extLst>
+          </p:cNvPr>
           <p:cNvSpPr>
             <a:spLocks noGrp="1"/>
           </p:cNvSpPr>
@@ -4178,136 +4514,39 @@
           <a:bodyPr/>
           <a:lstStyle/>
           <a:p>
-            <a:endParaRPr lang="ru-RU" dirty="0"/>
+            <a:endParaRPr lang="ru-RU"/>
           </a:p>
         </p:txBody>
       </p:sp>
       <p:pic>
         <p:nvPicPr>
-          <p:cNvPr id="3074" name="Picture 2"/>
+          <p:cNvPr id="15" name="Рисунок 14">
+            <a:extLst>
+              <a:ext uri="{FF2B5EF4-FFF2-40B4-BE49-F238E27FC236}">
+                <a16:creationId xmlns:a16="http://schemas.microsoft.com/office/drawing/2014/main" id="{51F5F192-B8DD-AB3A-752A-053FDF1871F0}"/>
+              </a:ext>
+            </a:extLst>
+          </p:cNvPr>
           <p:cNvPicPr>
-            <a:picLocks noChangeAspect="1" noChangeArrowheads="1"/>
+            <a:picLocks noChangeAspect="1"/>
           </p:cNvPicPr>
           <p:nvPr/>
         </p:nvPicPr>
         <p:blipFill>
-          <a:blip r:embed="rId2">
-            <a:extLst>
-              <a:ext uri="{28A0092B-C50C-407E-A947-70E740481C1C}">
-                <a14:useLocalDpi xmlns:a14="http://schemas.microsoft.com/office/drawing/2010/main" val="0"/>
-              </a:ext>
-            </a:extLst>
-          </a:blip>
-          <a:srcRect/>
+          <a:blip r:embed="rId2"/>
+          <a:srcRect r="5161"/>
           <a:stretch>
             <a:fillRect/>
           </a:stretch>
         </p:blipFill>
-        <p:spPr bwMode="auto">
+        <p:spPr>
           <a:xfrm>
-            <a:off x="493108" y="1268760"/>
-            <a:ext cx="8183348" cy="3962153"/>
+            <a:off x="371694" y="2996952"/>
+            <a:ext cx="8400612" cy="1277931"/>
           </a:xfrm>
           <a:prstGeom prst="rect">
             <a:avLst/>
           </a:prstGeom>
-          <a:noFill/>
-          <a:ln>
-            <a:noFill/>
-          </a:ln>
-          <a:effectLst/>
-          <a:extLst>
-            <a:ext uri="{909E8E84-426E-40DD-AFC4-6F175D3DCCD1}">
-              <a14:hiddenFill xmlns:a14="http://schemas.microsoft.com/office/drawing/2010/main">
-                <a:solidFill>
-                  <a:schemeClr val="accent1"/>
-                </a:solidFill>
-              </a14:hiddenFill>
-            </a:ext>
-            <a:ext uri="{91240B29-F687-4F45-9708-019B960494DF}">
-              <a14:hiddenLine xmlns:a14="http://schemas.microsoft.com/office/drawing/2010/main" w="9525">
-                <a:solidFill>
-                  <a:schemeClr val="tx1"/>
-                </a:solidFill>
-                <a:miter lim="800000"/>
-                <a:headEnd/>
-                <a:tailEnd/>
-              </a14:hiddenLine>
-            </a:ext>
-            <a:ext uri="{AF507438-7753-43E0-B8FC-AC1667EBCBE1}">
-              <a14:hiddenEffects xmlns:a14="http://schemas.microsoft.com/office/drawing/2010/main">
-                <a:effectLst>
-                  <a:outerShdw dist="35921" dir="2700000" algn="ctr" rotWithShape="0">
-                    <a:schemeClr val="bg2"/>
-                  </a:outerShdw>
-                </a:effectLst>
-              </a14:hiddenEffects>
-            </a:ext>
-          </a:extLst>
-        </p:spPr>
-      </p:pic>
-      <p:pic>
-        <p:nvPicPr>
-          <p:cNvPr id="3075" name="Picture 3"/>
-          <p:cNvPicPr>
-            <a:picLocks noChangeAspect="1" noChangeArrowheads="1"/>
-          </p:cNvPicPr>
-          <p:nvPr/>
-        </p:nvPicPr>
-        <p:blipFill>
-          <a:blip r:embed="rId3">
-            <a:extLst>
-              <a:ext uri="{28A0092B-C50C-407E-A947-70E740481C1C}">
-                <a14:useLocalDpi xmlns:a14="http://schemas.microsoft.com/office/drawing/2010/main" val="0"/>
-              </a:ext>
-            </a:extLst>
-          </a:blip>
-          <a:srcRect/>
-          <a:stretch>
-            <a:fillRect/>
-          </a:stretch>
-        </p:blipFill>
-        <p:spPr bwMode="auto">
-          <a:xfrm>
-            <a:off x="1475656" y="5301208"/>
-            <a:ext cx="5688631" cy="1378370"/>
-          </a:xfrm>
-          <a:prstGeom prst="rect">
-            <a:avLst/>
-          </a:prstGeom>
-          <a:noFill/>
-          <a:ln>
-            <a:noFill/>
-          </a:ln>
-          <a:effectLst/>
-          <a:extLst>
-            <a:ext uri="{909E8E84-426E-40DD-AFC4-6F175D3DCCD1}">
-              <a14:hiddenFill xmlns:a14="http://schemas.microsoft.com/office/drawing/2010/main">
-                <a:solidFill>
-                  <a:schemeClr val="accent1"/>
-                </a:solidFill>
-              </a14:hiddenFill>
-            </a:ext>
-            <a:ext uri="{91240B29-F687-4F45-9708-019B960494DF}">
-              <a14:hiddenLine xmlns:a14="http://schemas.microsoft.com/office/drawing/2010/main" w="9525">
-                <a:solidFill>
-                  <a:schemeClr val="tx1"/>
-                </a:solidFill>
-                <a:miter lim="800000"/>
-                <a:headEnd/>
-                <a:tailEnd/>
-              </a14:hiddenLine>
-            </a:ext>
-            <a:ext uri="{AF507438-7753-43E0-B8FC-AC1667EBCBE1}">
-              <a14:hiddenEffects xmlns:a14="http://schemas.microsoft.com/office/drawing/2010/main">
-                <a:effectLst>
-                  <a:outerShdw dist="35921" dir="2700000" algn="ctr" rotWithShape="0">
-                    <a:schemeClr val="bg2"/>
-                  </a:outerShdw>
-                </a:effectLst>
-              </a14:hiddenEffects>
-            </a:ext>
-          </a:extLst>
         </p:spPr>
       </p:pic>
     </p:spTree>
@@ -4320,13 +4559,6 @@
   <p:clrMapOvr>
     <a:masterClrMapping/>
   </p:clrMapOvr>
-  <p:timing>
-    <p:tnLst>
-      <p:par>
-        <p:cTn id="1" dur="indefinite" restart="never" nodeType="tmRoot"/>
-      </p:par>
-    </p:tnLst>
-  </p:timing>
 </p:sld>
 </file>
 
@@ -4335,7 +4567,13 @@
   <p:cSld>
     <p:spTree>
       <p:nvGrpSpPr>
-        <p:cNvPr id="1" name=""/>
+        <p:cNvPr id="1" name="">
+          <a:extLst>
+            <a:ext uri="{FF2B5EF4-FFF2-40B4-BE49-F238E27FC236}">
+              <a16:creationId xmlns:a16="http://schemas.microsoft.com/office/drawing/2014/main" id="{D154763E-076D-109A-49F8-AA28447C9FE8}"/>
+            </a:ext>
+          </a:extLst>
+        </p:cNvPr>
         <p:cNvGrpSpPr/>
         <p:nvPr/>
       </p:nvGrpSpPr>
@@ -4349,7 +4587,13 @@
       </p:grpSpPr>
       <p:sp>
         <p:nvSpPr>
-          <p:cNvPr id="2" name="Заголовок 1"/>
+          <p:cNvPr id="2" name="Заголовок 1">
+            <a:extLst>
+              <a:ext uri="{FF2B5EF4-FFF2-40B4-BE49-F238E27FC236}">
+                <a16:creationId xmlns:a16="http://schemas.microsoft.com/office/drawing/2014/main" id="{4AA4A36B-CB74-E4D1-0496-A4CF18F34AFA}"/>
+              </a:ext>
+            </a:extLst>
+          </p:cNvPr>
           <p:cNvSpPr>
             <a:spLocks noGrp="1"/>
           </p:cNvSpPr>
@@ -4357,7 +4601,12 @@
             <p:ph type="title"/>
           </p:nvPr>
         </p:nvSpPr>
-        <p:spPr/>
+        <p:spPr>
+          <a:xfrm>
+            <a:off x="457200" y="193240"/>
+            <a:ext cx="8229600" cy="1143000"/>
+          </a:xfrm>
+        </p:spPr>
         <p:txBody>
           <a:bodyPr>
             <a:noAutofit/>
@@ -4365,26 +4614,30 @@
           <a:lstStyle/>
           <a:p>
             <a:r>
-              <a:rPr lang="ru-RU" sz="3200" b="1" dirty="0" smtClean="0">
-                <a:latin typeface="Times New Roman" panose="02020603050405020304" pitchFamily="18" charset="0"/>
-                <a:cs typeface="Times New Roman" panose="02020603050405020304" pitchFamily="18" charset="0"/>
-              </a:rPr>
-              <a:t>Запись данных и раскладка chunk'ов по узлам</a:t>
-            </a:r>
-            <a:endParaRPr lang="ru-RU" sz="3200" b="1" dirty="0">
-              <a:latin typeface="Times New Roman" panose="02020603050405020304" pitchFamily="18" charset="0"/>
-              <a:cs typeface="Times New Roman" panose="02020603050405020304" pitchFamily="18" charset="0"/>
-            </a:endParaRPr>
+              <a:rPr lang="ru-RU" sz="3200" b="1" dirty="0">
+                <a:latin typeface="Times New Roman" panose="02020603050405020304" pitchFamily="18" charset="0"/>
+                <a:cs typeface="Times New Roman" panose="02020603050405020304" pitchFamily="18" charset="0"/>
+              </a:rPr>
+              <a:t>Клиент видит доступные storage-классы</a:t>
+            </a:r>
           </a:p>
         </p:txBody>
       </p:sp>
       <p:pic>
         <p:nvPicPr>
-          <p:cNvPr id="4098" name="Picture 2"/>
+          <p:cNvPr id="7" name="Объект 6">
+            <a:extLst>
+              <a:ext uri="{FF2B5EF4-FFF2-40B4-BE49-F238E27FC236}">
+                <a16:creationId xmlns:a16="http://schemas.microsoft.com/office/drawing/2014/main" id="{4E3335B2-5F70-003B-70F0-D640DAB51A77}"/>
+              </a:ext>
+            </a:extLst>
+          </p:cNvPr>
           <p:cNvPicPr>
-            <a:picLocks noChangeAspect="1" noChangeArrowheads="1"/>
+            <a:picLocks noGrp="1" noChangeAspect="1"/>
           </p:cNvPicPr>
-          <p:nvPr/>
+          <p:nvPr>
+            <p:ph idx="1"/>
+          </p:nvPr>
         </p:nvPicPr>
         <p:blipFill>
           <a:blip r:embed="rId2">
@@ -4394,135 +4647,30 @@
               </a:ext>
             </a:extLst>
           </a:blip>
-          <a:srcRect/>
           <a:stretch>
             <a:fillRect/>
           </a:stretch>
         </p:blipFill>
-        <p:spPr bwMode="auto">
+        <p:spPr>
           <a:xfrm>
-            <a:off x="179512" y="1582927"/>
-            <a:ext cx="8758462" cy="2134105"/>
+            <a:off x="1646310" y="1340768"/>
+            <a:ext cx="5878018" cy="4909036"/>
           </a:xfrm>
           <a:prstGeom prst="rect">
             <a:avLst/>
           </a:prstGeom>
-          <a:noFill/>
-          <a:ln>
-            <a:noFill/>
-          </a:ln>
-          <a:effectLst/>
-          <a:extLst>
-            <a:ext uri="{909E8E84-426E-40DD-AFC4-6F175D3DCCD1}">
-              <a14:hiddenFill xmlns:a14="http://schemas.microsoft.com/office/drawing/2010/main">
-                <a:solidFill>
-                  <a:schemeClr val="accent1"/>
-                </a:solidFill>
-              </a14:hiddenFill>
-            </a:ext>
-            <a:ext uri="{91240B29-F687-4F45-9708-019B960494DF}">
-              <a14:hiddenLine xmlns:a14="http://schemas.microsoft.com/office/drawing/2010/main" w="9525">
-                <a:solidFill>
-                  <a:schemeClr val="tx1"/>
-                </a:solidFill>
-                <a:miter lim="800000"/>
-                <a:headEnd/>
-                <a:tailEnd/>
-              </a14:hiddenLine>
-            </a:ext>
-            <a:ext uri="{AF507438-7753-43E0-B8FC-AC1667EBCBE1}">
-              <a14:hiddenEffects xmlns:a14="http://schemas.microsoft.com/office/drawing/2010/main">
-                <a:effectLst>
-                  <a:outerShdw dist="35921" dir="2700000" algn="ctr" rotWithShape="0">
-                    <a:schemeClr val="bg2"/>
-                  </a:outerShdw>
-                </a:effectLst>
-              </a14:hiddenEffects>
-            </a:ext>
-          </a:extLst>
-        </p:spPr>
-      </p:pic>
-      <p:pic>
-        <p:nvPicPr>
-          <p:cNvPr id="4099" name="Picture 3"/>
-          <p:cNvPicPr>
-            <a:picLocks noGrp="1" noChangeAspect="1" noChangeArrowheads="1"/>
-          </p:cNvPicPr>
-          <p:nvPr>
-            <p:ph idx="1"/>
-          </p:nvPr>
-        </p:nvPicPr>
-        <p:blipFill rotWithShape="1">
-          <a:blip r:embed="rId3">
-            <a:extLst>
-              <a:ext uri="{28A0092B-C50C-407E-A947-70E740481C1C}">
-                <a14:useLocalDpi xmlns:a14="http://schemas.microsoft.com/office/drawing/2010/main" val="0"/>
-              </a:ext>
-            </a:extLst>
-          </a:blip>
-          <a:srcRect r="3342"/>
-          <a:stretch/>
-        </p:blipFill>
-        <p:spPr bwMode="auto">
-          <a:xfrm>
-            <a:off x="179511" y="4077072"/>
-            <a:ext cx="8758463" cy="2017940"/>
-          </a:xfrm>
-          <a:prstGeom prst="rect">
-            <a:avLst/>
-          </a:prstGeom>
-          <a:noFill/>
-          <a:ln>
-            <a:noFill/>
-          </a:ln>
-          <a:effectLst/>
-          <a:extLst>
-            <a:ext uri="{909E8E84-426E-40DD-AFC4-6F175D3DCCD1}">
-              <a14:hiddenFill xmlns:a14="http://schemas.microsoft.com/office/drawing/2010/main">
-                <a:solidFill>
-                  <a:schemeClr val="accent1"/>
-                </a:solidFill>
-              </a14:hiddenFill>
-            </a:ext>
-            <a:ext uri="{91240B29-F687-4F45-9708-019B960494DF}">
-              <a14:hiddenLine xmlns:a14="http://schemas.microsoft.com/office/drawing/2010/main" w="9525">
-                <a:solidFill>
-                  <a:schemeClr val="tx1"/>
-                </a:solidFill>
-                <a:miter lim="800000"/>
-                <a:headEnd/>
-                <a:tailEnd/>
-              </a14:hiddenLine>
-            </a:ext>
-            <a:ext uri="{AF507438-7753-43E0-B8FC-AC1667EBCBE1}">
-              <a14:hiddenEffects xmlns:a14="http://schemas.microsoft.com/office/drawing/2010/main">
-                <a:effectLst>
-                  <a:outerShdw dist="35921" dir="2700000" algn="ctr" rotWithShape="0">
-                    <a:schemeClr val="bg2"/>
-                  </a:outerShdw>
-                </a:effectLst>
-              </a14:hiddenEffects>
-            </a:ext>
-          </a:extLst>
         </p:spPr>
       </p:pic>
     </p:spTree>
     <p:extLst>
       <p:ext uri="{BB962C8B-B14F-4D97-AF65-F5344CB8AC3E}">
-        <p14:creationId xmlns:p14="http://schemas.microsoft.com/office/powerpoint/2010/main" val="2297978276"/>
+        <p14:creationId xmlns:p14="http://schemas.microsoft.com/office/powerpoint/2010/main" val="2808073623"/>
       </p:ext>
     </p:extLst>
   </p:cSld>
   <p:clrMapOvr>
     <a:masterClrMapping/>
   </p:clrMapOvr>
-  <p:timing>
-    <p:tnLst>
-      <p:par>
-        <p:cTn id="1" dur="indefinite" restart="never" nodeType="tmRoot"/>
-      </p:par>
-    </p:tnLst>
-  </p:timing>
 </p:sld>
 </file>
 
@@ -4561,43 +4709,26 @@
           <a:lstStyle/>
           <a:p>
             <a:r>
-              <a:rPr lang="ru-RU" sz="3200" b="1" dirty="0" smtClean="0">
-                <a:latin typeface="Times New Roman" panose="02020603050405020304" pitchFamily="18" charset="0"/>
-                <a:cs typeface="Times New Roman" panose="02020603050405020304" pitchFamily="18" charset="0"/>
-              </a:rPr>
-              <a:t>Отказоустойчивость: чтение при упавшем узле</a:t>
-            </a:r>
-            <a:endParaRPr lang="ru-RU" sz="3200" b="1" dirty="0">
-              <a:latin typeface="Times New Roman" panose="02020603050405020304" pitchFamily="18" charset="0"/>
-              <a:cs typeface="Times New Roman" panose="02020603050405020304" pitchFamily="18" charset="0"/>
-            </a:endParaRPr>
-          </a:p>
-        </p:txBody>
-      </p:sp>
-      <p:sp>
-        <p:nvSpPr>
-          <p:cNvPr id="3" name="Объект 2"/>
-          <p:cNvSpPr>
-            <a:spLocks noGrp="1"/>
-          </p:cNvSpPr>
-          <p:nvPr>
-            <p:ph idx="1"/>
-          </p:nvPr>
-        </p:nvSpPr>
-        <p:spPr/>
-        <p:txBody>
-          <a:bodyPr/>
-          <a:lstStyle/>
-          <a:p>
-            <a:endParaRPr lang="ru-RU" dirty="0"/>
+              <a:rPr lang="ru-RU" sz="3200" b="1" dirty="0">
+                <a:latin typeface="Times New Roman" panose="02020603050405020304" pitchFamily="18" charset="0"/>
+                <a:cs typeface="Times New Roman" panose="02020603050405020304" pitchFamily="18" charset="0"/>
+              </a:rPr>
+              <a:t>Запись данных и раскладка chunk'ов по узлам</a:t>
+            </a:r>
           </a:p>
         </p:txBody>
       </p:sp>
       <p:pic>
         <p:nvPicPr>
-          <p:cNvPr id="5122" name="Picture 2"/>
+          <p:cNvPr id="4" name="Рисунок 3">
+            <a:extLst>
+              <a:ext uri="{FF2B5EF4-FFF2-40B4-BE49-F238E27FC236}">
+                <a16:creationId xmlns:a16="http://schemas.microsoft.com/office/drawing/2014/main" id="{DDD1D43B-A659-66CC-831F-407BA20D6E0C}"/>
+              </a:ext>
+            </a:extLst>
+          </p:cNvPr>
           <p:cNvPicPr>
-            <a:picLocks noChangeAspect="1" noChangeArrowheads="1"/>
+            <a:picLocks noChangeAspect="1"/>
           </p:cNvPicPr>
           <p:nvPr/>
         </p:nvPicPr>
@@ -4609,71 +4740,68 @@
               </a:ext>
             </a:extLst>
           </a:blip>
-          <a:srcRect/>
           <a:stretch>
             <a:fillRect/>
           </a:stretch>
         </p:blipFill>
-        <p:spPr bwMode="auto">
+        <p:spPr>
           <a:xfrm>
-            <a:off x="233363" y="2132856"/>
-            <a:ext cx="8677275" cy="3228975"/>
+            <a:off x="323528" y="1857370"/>
+            <a:ext cx="8496944" cy="1571630"/>
           </a:xfrm>
           <a:prstGeom prst="rect">
             <a:avLst/>
           </a:prstGeom>
-          <a:noFill/>
-          <a:ln>
-            <a:noFill/>
-          </a:ln>
-          <a:effectLst/>
-          <a:extLst>
-            <a:ext uri="{909E8E84-426E-40DD-AFC4-6F175D3DCCD1}">
-              <a14:hiddenFill xmlns:a14="http://schemas.microsoft.com/office/drawing/2010/main">
-                <a:solidFill>
-                  <a:schemeClr val="accent1"/>
-                </a:solidFill>
-              </a14:hiddenFill>
-            </a:ext>
-            <a:ext uri="{91240B29-F687-4F45-9708-019B960494DF}">
-              <a14:hiddenLine xmlns:a14="http://schemas.microsoft.com/office/drawing/2010/main" w="9525">
-                <a:solidFill>
-                  <a:schemeClr val="tx1"/>
-                </a:solidFill>
-                <a:miter lim="800000"/>
-                <a:headEnd/>
-                <a:tailEnd/>
-              </a14:hiddenLine>
-            </a:ext>
-            <a:ext uri="{AF507438-7753-43E0-B8FC-AC1667EBCBE1}">
-              <a14:hiddenEffects xmlns:a14="http://schemas.microsoft.com/office/drawing/2010/main">
-                <a:effectLst>
-                  <a:outerShdw dist="35921" dir="2700000" algn="ctr" rotWithShape="0">
-                    <a:schemeClr val="bg2"/>
-                  </a:outerShdw>
-                </a:effectLst>
-              </a14:hiddenEffects>
-            </a:ext>
-          </a:extLst>
+        </p:spPr>
+      </p:pic>
+      <p:pic>
+        <p:nvPicPr>
+          <p:cNvPr id="7" name="Объект 6">
+            <a:extLst>
+              <a:ext uri="{FF2B5EF4-FFF2-40B4-BE49-F238E27FC236}">
+                <a16:creationId xmlns:a16="http://schemas.microsoft.com/office/drawing/2014/main" id="{C15882DB-A3C4-C599-2C51-D8C19468F831}"/>
+              </a:ext>
+            </a:extLst>
+          </p:cNvPr>
+          <p:cNvPicPr>
+            <a:picLocks noGrp="1" noChangeAspect="1"/>
+          </p:cNvPicPr>
+          <p:nvPr>
+            <p:ph idx="1"/>
+          </p:nvPr>
+        </p:nvPicPr>
+        <p:blipFill>
+          <a:blip r:embed="rId3">
+            <a:extLst>
+              <a:ext uri="{28A0092B-C50C-407E-A947-70E740481C1C}">
+                <a14:useLocalDpi xmlns:a14="http://schemas.microsoft.com/office/drawing/2010/main" val="0"/>
+              </a:ext>
+            </a:extLst>
+          </a:blip>
+          <a:stretch>
+            <a:fillRect/>
+          </a:stretch>
+        </p:blipFill>
+        <p:spPr>
+          <a:xfrm>
+            <a:off x="323528" y="3988167"/>
+            <a:ext cx="8568952" cy="1169025"/>
+          </a:xfrm>
+          <a:prstGeom prst="rect">
+            <a:avLst/>
+          </a:prstGeom>
         </p:spPr>
       </p:pic>
     </p:spTree>
     <p:extLst>
       <p:ext uri="{BB962C8B-B14F-4D97-AF65-F5344CB8AC3E}">
-        <p14:creationId xmlns:p14="http://schemas.microsoft.com/office/powerpoint/2010/main" val="2584187405"/>
+        <p14:creationId xmlns:p14="http://schemas.microsoft.com/office/powerpoint/2010/main" val="2297978276"/>
       </p:ext>
     </p:extLst>
   </p:cSld>
   <p:clrMapOvr>
     <a:masterClrMapping/>
   </p:clrMapOvr>
-  <p:timing>
-    <p:tnLst>
-      <p:par>
-        <p:cTn id="1" dur="indefinite" restart="never" nodeType="tmRoot"/>
-      </p:par>
-    </p:tnLst>
-  </p:timing>
 </p:sld>
 </file>
 
@@ -4712,79 +4840,43 @@
           <a:lstStyle/>
           <a:p>
             <a:r>
-              <a:rPr lang="ru-RU" sz="3200" b="1" dirty="0" smtClean="0">
-                <a:latin typeface="Times New Roman" panose="02020603050405020304" pitchFamily="18" charset="0"/>
-                <a:cs typeface="Times New Roman" panose="02020603050405020304" pitchFamily="18" charset="0"/>
-              </a:rPr>
-              <a:t>Статус </a:t>
-            </a:r>
-            <a:r>
               <a:rPr lang="ru-RU" sz="3200" b="1" dirty="0">
                 <a:latin typeface="Times New Roman" panose="02020603050405020304" pitchFamily="18" charset="0"/>
                 <a:cs typeface="Times New Roman" panose="02020603050405020304" pitchFamily="18" charset="0"/>
               </a:rPr>
-              <a:t>кластера </a:t>
-            </a:r>
-            <a:r>
-              <a:rPr lang="ru-RU" sz="3200" b="1" dirty="0" smtClean="0">
-                <a:latin typeface="Times New Roman" panose="02020603050405020304" pitchFamily="18" charset="0"/>
-                <a:cs typeface="Times New Roman" panose="02020603050405020304" pitchFamily="18" charset="0"/>
-              </a:rPr>
-              <a:t/>
+              <a:t>Отказоустойчивость: </a:t>
             </a:r>
             <a:br>
-              <a:rPr lang="ru-RU" sz="3200" b="1" dirty="0" smtClean="0">
+              <a:rPr lang="ru-RU" sz="3200" b="1" dirty="0">
                 <a:latin typeface="Times New Roman" panose="02020603050405020304" pitchFamily="18" charset="0"/>
                 <a:cs typeface="Times New Roman" panose="02020603050405020304" pitchFamily="18" charset="0"/>
               </a:rPr>
             </a:br>
             <a:r>
-              <a:rPr lang="ru-RU" sz="3200" b="1" dirty="0" smtClean="0">
-                <a:latin typeface="Times New Roman" panose="02020603050405020304" pitchFamily="18" charset="0"/>
-                <a:cs typeface="Times New Roman" panose="02020603050405020304" pitchFamily="18" charset="0"/>
-              </a:rPr>
-              <a:t>через </a:t>
-            </a:r>
-            <a:r>
               <a:rPr lang="ru-RU" sz="3200" b="1" dirty="0">
                 <a:latin typeface="Times New Roman" panose="02020603050405020304" pitchFamily="18" charset="0"/>
                 <a:cs typeface="Times New Roman" panose="02020603050405020304" pitchFamily="18" charset="0"/>
               </a:rPr>
-              <a:t>CLI-утилиты MooseFS</a:t>
-            </a:r>
-            <a:endParaRPr lang="ru-RU" sz="3200" b="1" dirty="0">
-              <a:latin typeface="Times New Roman" panose="02020603050405020304" pitchFamily="18" charset="0"/>
-              <a:cs typeface="Times New Roman" panose="02020603050405020304" pitchFamily="18" charset="0"/>
-            </a:endParaRPr>
-          </a:p>
-        </p:txBody>
-      </p:sp>
-      <p:sp>
-        <p:nvSpPr>
-          <p:cNvPr id="3" name="Объект 2"/>
-          <p:cNvSpPr>
-            <a:spLocks noGrp="1"/>
-          </p:cNvSpPr>
-          <p:nvPr>
-            <p:ph idx="1"/>
-          </p:nvPr>
-        </p:nvSpPr>
-        <p:spPr/>
-        <p:txBody>
-          <a:bodyPr/>
-          <a:lstStyle/>
-          <a:p>
-            <a:endParaRPr lang="ru-RU" dirty="0"/>
+              <a:t>чтение при упавшем узле</a:t>
+            </a:r>
           </a:p>
         </p:txBody>
       </p:sp>
       <p:pic>
         <p:nvPicPr>
-          <p:cNvPr id="6146" name="Picture 2"/>
+          <p:cNvPr id="5" name="Объект 4">
+            <a:extLst>
+              <a:ext uri="{FF2B5EF4-FFF2-40B4-BE49-F238E27FC236}">
+                <a16:creationId xmlns:a16="http://schemas.microsoft.com/office/drawing/2014/main" id="{E9432F8F-7FF3-0856-70A5-5E4FDE89036D}"/>
+              </a:ext>
+            </a:extLst>
+          </p:cNvPr>
           <p:cNvPicPr>
-            <a:picLocks noChangeAspect="1" noChangeArrowheads="1"/>
+            <a:picLocks noGrp="1" noChangeAspect="1"/>
           </p:cNvPicPr>
-          <p:nvPr/>
+          <p:nvPr>
+            <p:ph idx="1"/>
+          </p:nvPr>
         </p:nvPicPr>
         <p:blipFill>
           <a:blip r:embed="rId2">
@@ -4794,71 +4886,30 @@
               </a:ext>
             </a:extLst>
           </a:blip>
-          <a:srcRect/>
           <a:stretch>
             <a:fillRect/>
           </a:stretch>
         </p:blipFill>
-        <p:spPr bwMode="auto">
+        <p:spPr>
           <a:xfrm>
-            <a:off x="179512" y="2270406"/>
-            <a:ext cx="8784976" cy="2814778"/>
+            <a:off x="260944" y="2420888"/>
+            <a:ext cx="8622112" cy="2428268"/>
           </a:xfrm>
           <a:prstGeom prst="rect">
             <a:avLst/>
           </a:prstGeom>
-          <a:noFill/>
-          <a:ln>
-            <a:noFill/>
-          </a:ln>
-          <a:effectLst/>
-          <a:extLst>
-            <a:ext uri="{909E8E84-426E-40DD-AFC4-6F175D3DCCD1}">
-              <a14:hiddenFill xmlns:a14="http://schemas.microsoft.com/office/drawing/2010/main">
-                <a:solidFill>
-                  <a:schemeClr val="accent1"/>
-                </a:solidFill>
-              </a14:hiddenFill>
-            </a:ext>
-            <a:ext uri="{91240B29-F687-4F45-9708-019B960494DF}">
-              <a14:hiddenLine xmlns:a14="http://schemas.microsoft.com/office/drawing/2010/main" w="9525">
-                <a:solidFill>
-                  <a:schemeClr val="tx1"/>
-                </a:solidFill>
-                <a:miter lim="800000"/>
-                <a:headEnd/>
-                <a:tailEnd/>
-              </a14:hiddenLine>
-            </a:ext>
-            <a:ext uri="{AF507438-7753-43E0-B8FC-AC1667EBCBE1}">
-              <a14:hiddenEffects xmlns:a14="http://schemas.microsoft.com/office/drawing/2010/main">
-                <a:effectLst>
-                  <a:outerShdw dist="35921" dir="2700000" algn="ctr" rotWithShape="0">
-                    <a:schemeClr val="bg2"/>
-                  </a:outerShdw>
-                </a:effectLst>
-              </a14:hiddenEffects>
-            </a:ext>
-          </a:extLst>
         </p:spPr>
       </p:pic>
     </p:spTree>
     <p:extLst>
       <p:ext uri="{BB962C8B-B14F-4D97-AF65-F5344CB8AC3E}">
-        <p14:creationId xmlns:p14="http://schemas.microsoft.com/office/powerpoint/2010/main" val="1199332915"/>
+        <p14:creationId xmlns:p14="http://schemas.microsoft.com/office/powerpoint/2010/main" val="2584187405"/>
       </p:ext>
     </p:extLst>
   </p:cSld>
   <p:clrMapOvr>
     <a:masterClrMapping/>
   </p:clrMapOvr>
-  <p:timing>
-    <p:tnLst>
-      <p:par>
-        <p:cTn id="1" dur="indefinite" restart="never" nodeType="tmRoot"/>
-      </p:par>
-    </p:tnLst>
-  </p:timing>
 </p:sld>
 </file>
 
@@ -4901,381 +4952,73 @@
                 <a:latin typeface="Times New Roman" panose="02020603050405020304" pitchFamily="18" charset="0"/>
                 <a:cs typeface="Times New Roman" panose="02020603050405020304" pitchFamily="18" charset="0"/>
               </a:rPr>
-              <a:t>Заключение</a:t>
-            </a:r>
-          </a:p>
-        </p:txBody>
-      </p:sp>
-      <p:sp>
-        <p:nvSpPr>
-          <p:cNvPr id="3" name="Объект 2"/>
-          <p:cNvSpPr>
-            <a:spLocks noGrp="1"/>
-          </p:cNvSpPr>
+              <a:t>Статус кластера </a:t>
+            </a:r>
+            <a:br>
+              <a:rPr lang="ru-RU" sz="3200" b="1" dirty="0">
+                <a:latin typeface="Times New Roman" panose="02020603050405020304" pitchFamily="18" charset="0"/>
+                <a:cs typeface="Times New Roman" panose="02020603050405020304" pitchFamily="18" charset="0"/>
+              </a:rPr>
+            </a:br>
+            <a:r>
+              <a:rPr lang="ru-RU" sz="3200" b="1" dirty="0">
+                <a:latin typeface="Times New Roman" panose="02020603050405020304" pitchFamily="18" charset="0"/>
+                <a:cs typeface="Times New Roman" panose="02020603050405020304" pitchFamily="18" charset="0"/>
+              </a:rPr>
+              <a:t>через CLI-утилиты MooseFS</a:t>
+            </a:r>
+          </a:p>
+        </p:txBody>
+      </p:sp>
+      <p:pic>
+        <p:nvPicPr>
+          <p:cNvPr id="5" name="Объект 4">
+            <a:extLst>
+              <a:ext uri="{FF2B5EF4-FFF2-40B4-BE49-F238E27FC236}">
+                <a16:creationId xmlns:a16="http://schemas.microsoft.com/office/drawing/2014/main" id="{AD275F06-CCEF-3833-F5B1-58C78433BD79}"/>
+              </a:ext>
+            </a:extLst>
+          </p:cNvPr>
+          <p:cNvPicPr>
+            <a:picLocks noGrp="1" noChangeAspect="1"/>
+          </p:cNvPicPr>
           <p:nvPr>
             <p:ph idx="1"/>
           </p:nvPr>
-        </p:nvSpPr>
+        </p:nvPicPr>
+        <p:blipFill>
+          <a:blip r:embed="rId2">
+            <a:extLst>
+              <a:ext uri="{28A0092B-C50C-407E-A947-70E740481C1C}">
+                <a14:useLocalDpi xmlns:a14="http://schemas.microsoft.com/office/drawing/2010/main" val="0"/>
+              </a:ext>
+            </a:extLst>
+          </a:blip>
+          <a:srcRect r="11393"/>
+          <a:stretch>
+            <a:fillRect/>
+          </a:stretch>
+        </p:blipFill>
         <p:spPr>
           <a:xfrm>
-            <a:off x="467544" y="1268760"/>
-            <a:ext cx="8219256" cy="5001419"/>
+            <a:off x="375417" y="2276872"/>
+            <a:ext cx="8348101" cy="2638969"/>
           </a:xfrm>
+          <a:prstGeom prst="rect">
+            <a:avLst/>
+          </a:prstGeom>
         </p:spPr>
-        <p:txBody>
-          <a:bodyPr>
-            <a:normAutofit fontScale="70000" lnSpcReduction="20000"/>
-          </a:bodyPr>
-          <a:lstStyle/>
-          <a:p>
-            <a:pPr marL="0" indent="0" algn="just">
-              <a:buNone/>
-            </a:pPr>
-            <a:r>
-              <a:rPr lang="ru-RU" sz="2600" b="1" dirty="0" smtClean="0">
-                <a:latin typeface="Times New Roman" panose="02020603050405020304" pitchFamily="18" charset="0"/>
-                <a:cs typeface="Times New Roman" panose="02020603050405020304" pitchFamily="18" charset="0"/>
-              </a:rPr>
-              <a:t>Подтвержденные </a:t>
-            </a:r>
-            <a:r>
-              <a:rPr lang="ru-RU" sz="2600" b="1" dirty="0">
-                <a:latin typeface="Times New Roman" panose="02020603050405020304" pitchFamily="18" charset="0"/>
-                <a:cs typeface="Times New Roman" panose="02020603050405020304" pitchFamily="18" charset="0"/>
-              </a:rPr>
-              <a:t>возможности</a:t>
-            </a:r>
-            <a:r>
-              <a:rPr lang="ru-RU" sz="2600" b="1" dirty="0" smtClean="0">
-                <a:latin typeface="Times New Roman" panose="02020603050405020304" pitchFamily="18" charset="0"/>
-                <a:cs typeface="Times New Roman" panose="02020603050405020304" pitchFamily="18" charset="0"/>
-              </a:rPr>
-              <a:t>:</a:t>
-            </a:r>
-          </a:p>
-          <a:p>
-            <a:pPr marL="0" indent="0" algn="just">
-              <a:buNone/>
-            </a:pPr>
-            <a:endParaRPr lang="ru-RU" sz="2600" b="1" dirty="0">
-              <a:latin typeface="Times New Roman" panose="02020603050405020304" pitchFamily="18" charset="0"/>
-              <a:cs typeface="Times New Roman" panose="02020603050405020304" pitchFamily="18" charset="0"/>
-            </a:endParaRPr>
-          </a:p>
-          <a:p>
-            <a:pPr algn="just"/>
-            <a:r>
-              <a:rPr lang="ru-RU" sz="2600" b="1" dirty="0" smtClean="0">
-                <a:latin typeface="Times New Roman" panose="02020603050405020304" pitchFamily="18" charset="0"/>
-                <a:cs typeface="Times New Roman" panose="02020603050405020304" pitchFamily="18" charset="0"/>
-              </a:rPr>
-              <a:t>Единое пространство имён </a:t>
-            </a:r>
-            <a:r>
-              <a:rPr lang="ru-RU" sz="2600" b="1" dirty="0">
-                <a:latin typeface="Times New Roman" panose="02020603050405020304" pitchFamily="18" charset="0"/>
-                <a:cs typeface="Times New Roman" panose="02020603050405020304" pitchFamily="18" charset="0"/>
-              </a:rPr>
-              <a:t>— клиент видит один раздел </a:t>
-            </a:r>
-            <a:r>
-              <a:rPr lang="ru-RU" sz="2600" b="1" dirty="0" smtClean="0">
-                <a:latin typeface="Times New Roman" panose="02020603050405020304" pitchFamily="18" charset="0"/>
-                <a:cs typeface="Times New Roman" panose="02020603050405020304" pitchFamily="18" charset="0"/>
-              </a:rPr>
-              <a:t>/mnt/mfs</a:t>
-            </a:r>
-            <a:r>
-              <a:rPr lang="ru-RU" sz="2600" dirty="0">
-                <a:latin typeface="Times New Roman" panose="02020603050405020304" pitchFamily="18" charset="0"/>
-                <a:cs typeface="Times New Roman" panose="02020603050405020304" pitchFamily="18" charset="0"/>
-              </a:rPr>
-              <a:t>,</a:t>
-            </a:r>
-            <a:r>
-              <a:rPr lang="ru-RU" sz="2600" b="1" dirty="0">
-                <a:latin typeface="Times New Roman" panose="02020603050405020304" pitchFamily="18" charset="0"/>
-                <a:cs typeface="Times New Roman" panose="02020603050405020304" pitchFamily="18" charset="0"/>
-              </a:rPr>
-              <a:t> </a:t>
-            </a:r>
-            <a:r>
-              <a:rPr lang="ru-RU" sz="2600" dirty="0" err="1">
-                <a:latin typeface="Times New Roman" panose="02020603050405020304" pitchFamily="18" charset="0"/>
-                <a:cs typeface="Times New Roman" panose="02020603050405020304" pitchFamily="18" charset="0"/>
-              </a:rPr>
-              <a:t>MooseFS</a:t>
-            </a:r>
-            <a:r>
-              <a:rPr lang="ru-RU" sz="2600" dirty="0">
-                <a:latin typeface="Times New Roman" panose="02020603050405020304" pitchFamily="18" charset="0"/>
-                <a:cs typeface="Times New Roman" panose="02020603050405020304" pitchFamily="18" charset="0"/>
-              </a:rPr>
-              <a:t> распределённый по трём chunk-серверам.</a:t>
-            </a:r>
-          </a:p>
-          <a:p>
-            <a:pPr algn="just"/>
-            <a:r>
-              <a:rPr lang="ru-RU" sz="2600" b="1" dirty="0" smtClean="0">
-                <a:latin typeface="Times New Roman" panose="02020603050405020304" pitchFamily="18" charset="0"/>
-                <a:cs typeface="Times New Roman" panose="02020603050405020304" pitchFamily="18" charset="0"/>
-              </a:rPr>
-              <a:t>Репликация </a:t>
-            </a:r>
-            <a:r>
-              <a:rPr lang="ru-RU" sz="2600" dirty="0">
-                <a:latin typeface="Times New Roman" panose="02020603050405020304" pitchFamily="18" charset="0"/>
-                <a:cs typeface="Times New Roman" panose="02020603050405020304" pitchFamily="18" charset="0"/>
-              </a:rPr>
-              <a:t>— класс 3CP хранит по 3 копии каждого chunk'а на 3 разных узлах.</a:t>
-            </a:r>
-          </a:p>
-          <a:p>
-            <a:pPr algn="just"/>
-            <a:r>
-              <a:rPr lang="ru-RU" sz="2600" b="1" dirty="0" smtClean="0">
-                <a:latin typeface="Times New Roman" panose="02020603050405020304" pitchFamily="18" charset="0"/>
-                <a:cs typeface="Times New Roman" panose="02020603050405020304" pitchFamily="18" charset="0"/>
-              </a:rPr>
-              <a:t>Разбиение </a:t>
-            </a:r>
-            <a:r>
-              <a:rPr lang="ru-RU" sz="2600" b="1" dirty="0" err="1" smtClean="0">
-                <a:latin typeface="Times New Roman" panose="02020603050405020304" pitchFamily="18" charset="0"/>
-                <a:cs typeface="Times New Roman" panose="02020603050405020304" pitchFamily="18" charset="0"/>
-              </a:rPr>
-              <a:t>на chunk'ы</a:t>
-            </a:r>
-            <a:r>
-              <a:rPr lang="ru-RU" sz="2600" b="1" dirty="0" smtClean="0">
-                <a:latin typeface="Times New Roman" panose="02020603050405020304" pitchFamily="18" charset="0"/>
-                <a:cs typeface="Times New Roman" panose="02020603050405020304" pitchFamily="18" charset="0"/>
-              </a:rPr>
-              <a:t> </a:t>
-            </a:r>
-            <a:r>
-              <a:rPr lang="ru-RU" sz="2600" dirty="0">
-                <a:latin typeface="Times New Roman" panose="02020603050405020304" pitchFamily="18" charset="0"/>
-                <a:cs typeface="Times New Roman" panose="02020603050405020304" pitchFamily="18" charset="0"/>
-              </a:rPr>
-              <a:t>— файл 100 МБ разбит на 2 chunk'а (64 + 36), каждый реплицируется отдельно </a:t>
-            </a:r>
-            <a:r>
-              <a:rPr lang="ru-RU" sz="2600" dirty="0" err="1">
-                <a:latin typeface="Times New Roman" panose="02020603050405020304" pitchFamily="18" charset="0"/>
-                <a:cs typeface="Times New Roman" panose="02020603050405020304" pitchFamily="18" charset="0"/>
-              </a:rPr>
-              <a:t>(mfsfileinfo)</a:t>
-            </a:r>
-            <a:r>
-              <a:rPr lang="ru-RU" sz="2600" dirty="0">
-                <a:latin typeface="Times New Roman" panose="02020603050405020304" pitchFamily="18" charset="0"/>
-                <a:cs typeface="Times New Roman" panose="02020603050405020304" pitchFamily="18" charset="0"/>
-              </a:rPr>
-              <a:t>.</a:t>
-            </a:r>
-          </a:p>
-          <a:p>
-            <a:pPr algn="just"/>
-            <a:r>
-              <a:rPr lang="ru-RU" sz="2600" b="1" dirty="0" smtClean="0">
-                <a:latin typeface="Times New Roman" panose="02020603050405020304" pitchFamily="18" charset="0"/>
-                <a:cs typeface="Times New Roman" panose="02020603050405020304" pitchFamily="18" charset="0"/>
-              </a:rPr>
-              <a:t>Отказоустойчивость N−1 </a:t>
-            </a:r>
-            <a:r>
-              <a:rPr lang="ru-RU" sz="2600" dirty="0">
-                <a:latin typeface="Times New Roman" panose="02020603050405020304" pitchFamily="18" charset="0"/>
-                <a:cs typeface="Times New Roman" panose="02020603050405020304" pitchFamily="18" charset="0"/>
-              </a:rPr>
-              <a:t>— при остановке </a:t>
-            </a:r>
-            <a:r>
-              <a:rPr lang="ru-RU" sz="2600" dirty="0" err="1">
-                <a:latin typeface="Times New Roman" panose="02020603050405020304" pitchFamily="18" charset="0"/>
-                <a:cs typeface="Times New Roman" panose="02020603050405020304" pitchFamily="18" charset="0"/>
-              </a:rPr>
-              <a:t>одного</a:t>
-            </a:r>
-            <a:r>
-              <a:rPr lang="ru-RU" sz="2600" dirty="0">
-                <a:latin typeface="Times New Roman" panose="02020603050405020304" pitchFamily="18" charset="0"/>
-                <a:cs typeface="Times New Roman" panose="02020603050405020304" pitchFamily="18" charset="0"/>
-              </a:rPr>
-              <a:t> chunk-сервера md5sum 100 МБ файла возвращает корректные данные с оставшихся копий.</a:t>
-            </a:r>
-          </a:p>
-          <a:p>
-            <a:pPr algn="just"/>
-            <a:r>
-              <a:rPr lang="ru-RU" sz="2600" b="1" dirty="0" smtClean="0">
-                <a:latin typeface="Times New Roman" panose="02020603050405020304" pitchFamily="18" charset="0"/>
-                <a:cs typeface="Times New Roman" panose="02020603050405020304" pitchFamily="18" charset="0"/>
-              </a:rPr>
-              <a:t>Самовосстановление </a:t>
-            </a:r>
-            <a:r>
-              <a:rPr lang="ru-RU" sz="2600" dirty="0">
-                <a:latin typeface="Times New Roman" panose="02020603050405020304" pitchFamily="18" charset="0"/>
-                <a:cs typeface="Times New Roman" panose="02020603050405020304" pitchFamily="18" charset="0"/>
-              </a:rPr>
-              <a:t>— после возврата узла мастер запускает replication jobs и восстанавливает копии.</a:t>
-            </a:r>
-          </a:p>
-          <a:p>
-            <a:pPr algn="just"/>
-            <a:r>
-              <a:rPr lang="ru-RU" sz="2600" b="1" dirty="0" smtClean="0">
-                <a:latin typeface="Times New Roman" panose="02020603050405020304" pitchFamily="18" charset="0"/>
-                <a:cs typeface="Times New Roman" panose="02020603050405020304" pitchFamily="18" charset="0"/>
-              </a:rPr>
-              <a:t>Резервирование метаданных </a:t>
-            </a:r>
-            <a:r>
-              <a:rPr lang="ru-RU" sz="2600" dirty="0">
-                <a:latin typeface="Times New Roman" panose="02020603050405020304" pitchFamily="18" charset="0"/>
-                <a:cs typeface="Times New Roman" panose="02020603050405020304" pitchFamily="18" charset="0"/>
-              </a:rPr>
-              <a:t>— metalogger </a:t>
-            </a:r>
-            <a:r>
-              <a:rPr lang="ru-RU" sz="2600" dirty="0" err="1">
-                <a:latin typeface="Times New Roman" panose="02020603050405020304" pitchFamily="18" charset="0"/>
-                <a:cs typeface="Times New Roman" panose="02020603050405020304" pitchFamily="18" charset="0"/>
-              </a:rPr>
-              <a:t>MooseFS</a:t>
-            </a:r>
-            <a:r>
-              <a:rPr lang="ru-RU" sz="2600" dirty="0">
-                <a:latin typeface="Times New Roman" panose="02020603050405020304" pitchFamily="18" charset="0"/>
-                <a:cs typeface="Times New Roman" panose="02020603050405020304" pitchFamily="18" charset="0"/>
-              </a:rPr>
-              <a:t> непрерывно тянет с мастера журнал изменений metadata.mfs.</a:t>
-            </a:r>
-          </a:p>
-          <a:p>
-            <a:pPr algn="just"/>
-            <a:r>
-              <a:rPr lang="ru-RU" sz="2600" b="1" dirty="0" smtClean="0">
-                <a:latin typeface="Times New Roman" panose="02020603050405020304" pitchFamily="18" charset="0"/>
-                <a:cs typeface="Times New Roman" panose="02020603050405020304" pitchFamily="18" charset="0"/>
-              </a:rPr>
-              <a:t>Мониторинг </a:t>
-            </a:r>
-            <a:r>
-              <a:rPr lang="ru-RU" sz="2600" dirty="0">
-                <a:latin typeface="Times New Roman" panose="02020603050405020304" pitchFamily="18" charset="0"/>
-                <a:cs typeface="Times New Roman" panose="02020603050405020304" pitchFamily="18" charset="0"/>
-              </a:rPr>
-              <a:t>— штатные утилиты </a:t>
-            </a:r>
-            <a:r>
-              <a:rPr lang="ru-RU" sz="2600" dirty="0" err="1">
-                <a:latin typeface="Times New Roman" panose="02020603050405020304" pitchFamily="18" charset="0"/>
-                <a:cs typeface="Times New Roman" panose="02020603050405020304" pitchFamily="18" charset="0"/>
-              </a:rPr>
-              <a:t>MooseFS 4</a:t>
-            </a:r>
-            <a:r>
-              <a:rPr lang="ru-RU" sz="2600" dirty="0">
-                <a:latin typeface="Times New Roman" panose="02020603050405020304" pitchFamily="18" charset="0"/>
-                <a:cs typeface="Times New Roman" panose="02020603050405020304" pitchFamily="18" charset="0"/>
-              </a:rPr>
-              <a:t>: mfsfileinfo, mfscheckfile, mfsdirinfo, mfsgetsclass -r и docker logs.</a:t>
-            </a:r>
-          </a:p>
-          <a:p>
-            <a:pPr marL="0" indent="0" algn="just">
-              <a:buNone/>
-            </a:pPr>
-            <a:endParaRPr lang="ru-RU" sz="2600" b="1" dirty="0">
-              <a:latin typeface="Times New Roman" panose="02020603050405020304" pitchFamily="18" charset="0"/>
-              <a:cs typeface="Times New Roman" panose="02020603050405020304" pitchFamily="18" charset="0"/>
-            </a:endParaRPr>
-          </a:p>
-          <a:p>
-            <a:pPr marL="0" indent="0" algn="just">
-              <a:buNone/>
-            </a:pPr>
-            <a:endParaRPr lang="ru-RU" sz="2600" b="1" dirty="0">
-              <a:latin typeface="Times New Roman" panose="02020603050405020304" pitchFamily="18" charset="0"/>
-              <a:cs typeface="Times New Roman" panose="02020603050405020304" pitchFamily="18" charset="0"/>
-            </a:endParaRPr>
-          </a:p>
-          <a:p>
-            <a:pPr marL="0" indent="0" algn="just">
-              <a:buNone/>
-            </a:pPr>
-            <a:r>
-              <a:rPr lang="ru-RU" sz="2600" dirty="0">
-                <a:latin typeface="Times New Roman" panose="02020603050405020304" pitchFamily="18" charset="0"/>
-                <a:cs typeface="Times New Roman" panose="02020603050405020304" pitchFamily="18" charset="0"/>
-              </a:rPr>
-              <a:t> </a:t>
-            </a:r>
-            <a:r>
-              <a:rPr lang="ru-RU" sz="2600" dirty="0" smtClean="0">
-                <a:latin typeface="Times New Roman" panose="02020603050405020304" pitchFamily="18" charset="0"/>
-                <a:cs typeface="Times New Roman" panose="02020603050405020304" pitchFamily="18" charset="0"/>
-              </a:rPr>
-              <a:t>      Стенд </a:t>
-            </a:r>
-            <a:r>
-              <a:rPr lang="ru-RU" sz="2600" dirty="0" err="1">
-                <a:latin typeface="Times New Roman" panose="02020603050405020304" pitchFamily="18" charset="0"/>
-                <a:cs typeface="Times New Roman" panose="02020603050405020304" pitchFamily="18" charset="0"/>
-              </a:rPr>
-              <a:t>MooseFS</a:t>
-            </a:r>
-            <a:r>
-              <a:rPr lang="ru-RU" sz="2600" dirty="0">
-                <a:latin typeface="Times New Roman" panose="02020603050405020304" pitchFamily="18" charset="0"/>
-                <a:cs typeface="Times New Roman" panose="02020603050405020304" pitchFamily="18" charset="0"/>
-              </a:rPr>
-              <a:t> в мультинодовом режиме </a:t>
-            </a:r>
-            <a:r>
-              <a:rPr lang="ru-RU" sz="2600" dirty="0" err="1">
-                <a:latin typeface="Times New Roman" panose="02020603050405020304" pitchFamily="18" charset="0"/>
-                <a:cs typeface="Times New Roman" panose="02020603050405020304" pitchFamily="18" charset="0"/>
-              </a:rPr>
-              <a:t>(Docker Compose)</a:t>
-            </a:r>
-            <a:r>
-              <a:rPr lang="ru-RU" sz="2600" dirty="0">
-                <a:latin typeface="Times New Roman" panose="02020603050405020304" pitchFamily="18" charset="0"/>
-                <a:cs typeface="Times New Roman" panose="02020603050405020304" pitchFamily="18" charset="0"/>
-              </a:rPr>
-              <a:t> полностью работоспособен и демонстрирует ключевые свойства распределённой файловой системы: горизонтальное масштабирование хранилища, прозрачную репликацию chunk'ов и устойчивость к отказу отдельных узлов. Все тесты пройдены успешно.</a:t>
-            </a:r>
-          </a:p>
-          <a:p>
-            <a:pPr marL="0" indent="0" algn="just">
-              <a:buNone/>
-            </a:pPr>
-            <a:endParaRPr lang="ru-RU" dirty="0"/>
-          </a:p>
-        </p:txBody>
-      </p:sp>
+      </p:pic>
     </p:spTree>
     <p:extLst>
       <p:ext uri="{BB962C8B-B14F-4D97-AF65-F5344CB8AC3E}">
-        <p14:creationId xmlns:p14="http://schemas.microsoft.com/office/powerpoint/2010/main" val="3987295580"/>
+        <p14:creationId xmlns:p14="http://schemas.microsoft.com/office/powerpoint/2010/main" val="1199332915"/>
       </p:ext>
     </p:extLst>
   </p:cSld>
   <p:clrMapOvr>
     <a:masterClrMapping/>
   </p:clrMapOvr>
-  <p:timing>
-    <p:tnLst>
-      <p:par>
-        <p:cTn id="1" dur="indefinite" restart="never" nodeType="tmRoot"/>
-      </p:par>
-    </p:tnLst>
-  </p:timing>
 </p:sld>
 </file>
 

</xml_diff>